<commit_message>
Initial commit: AI Stock Pro Analyst
</commit_message>
<xml_diff>
--- a/Smart_Stock_Market_PPT.pptx
+++ b/Smart_Stock_Market_PPT.pptx
@@ -5,16 +5,17 @@
     <p:sldMasterId id="2147483665" r:id="rId4"/>
   </p:sldMasterIdLst>
   <p:notesMasterIdLst>
-    <p:notesMasterId r:id="rId12"/>
+    <p:notesMasterId r:id="rId13"/>
   </p:notesMasterIdLst>
   <p:sldIdLst>
     <p:sldId id="292" r:id="rId5"/>
     <p:sldId id="1291" r:id="rId6"/>
     <p:sldId id="1292" r:id="rId7"/>
     <p:sldId id="1294" r:id="rId8"/>
-    <p:sldId id="1293" r:id="rId9"/>
-    <p:sldId id="1296" r:id="rId10"/>
-    <p:sldId id="1250" r:id="rId11"/>
+    <p:sldId id="1297" r:id="rId9"/>
+    <p:sldId id="1293" r:id="rId10"/>
+    <p:sldId id="1296" r:id="rId11"/>
+    <p:sldId id="1250" r:id="rId12"/>
   </p:sldIdLst>
   <p:sldSz cx="9144000" cy="5143500" type="screen16x9"/>
   <p:notesSz cx="6858000" cy="9144000"/>
@@ -268,7 +269,7 @@
       </p15:sldGuideLst>
     </p:ext>
     <p:ext uri="http://customooxmlschemas.google.com/">
-      <go:slidesCustomData xmlns:mc="http://schemas.openxmlformats.org/markup-compatibility/2006" xmlns:mv="urn:schemas-microsoft-com:mac:vml" xmlns:c="http://schemas.openxmlformats.org/drawingml/2006/chart" xmlns:dgm="http://schemas.openxmlformats.org/drawingml/2006/diagram" xmlns:o="urn:schemas-microsoft-com:office:office" xmlns:v="urn:schemas-microsoft-com:vml" xmlns:pvml="urn:schemas-microsoft-com:office:powerpoint" xmlns:com="http://schemas.openxmlformats.org/drawingml/2006/compatibility" xmlns:p14="http://schemas.microsoft.com/office/powerpoint/2010/main" xmlns:p15="http://schemas.microsoft.com/office/powerpoint/2012/main" xmlns:go="http://customooxmlschemas.google.com/" xmlns="" r:id="rId220" roundtripDataSignature="AMtx7miWNY2LB4ETJwrL8F0N+EK9hEhqUQ=="/>
+      <go:slidesCustomData xmlns="" xmlns:go="http://customooxmlschemas.google.com/" xmlns:p15="http://schemas.microsoft.com/office/powerpoint/2012/main" xmlns:p14="http://schemas.microsoft.com/office/powerpoint/2010/main" xmlns:com="http://schemas.openxmlformats.org/drawingml/2006/compatibility" xmlns:pvml="urn:schemas-microsoft-com:office:powerpoint" xmlns:v="urn:schemas-microsoft-com:vml" xmlns:o="urn:schemas-microsoft-com:office:office" xmlns:dgm="http://schemas.openxmlformats.org/drawingml/2006/diagram" xmlns:c="http://schemas.openxmlformats.org/drawingml/2006/chart" xmlns:mv="urn:schemas-microsoft-com:mac:vml" xmlns:mc="http://schemas.openxmlformats.org/markup-compatibility/2006" r:id="rId220" roundtripDataSignature="AMtx7miWNY2LB4ETJwrL8F0N+EK9hEhqUQ=="/>
     </p:ext>
   </p:extLst>
 </p:presentation>
@@ -2189,7 +2190,7 @@
           <a:p>
             <a:fld id="{757799B1-BD81-4C27-AC39-14752E0AA9C5}" type="datetimeFigureOut">
               <a:rPr lang="en-IN" smtClean="0"/>
-              <a:t>29-05-2026</a:t>
+              <a:t>04-06-2026</a:t>
             </a:fld>
             <a:endParaRPr lang="en-IN"/>
           </a:p>
@@ -3292,12 +3293,12 @@
         </p:nvPicPr>
         <p:blipFill>
           <a:blip r:embed="rId3"/>
-          <a:srcRect l="11363" r="11363"/>
+          <a:srcRect t="1685" b="1685"/>
           <a:stretch/>
         </p:blipFill>
         <p:spPr>
           <a:xfrm>
-            <a:off x="3277989" y="-11911"/>
+            <a:off x="3267706" y="-3992"/>
             <a:ext cx="5896498" cy="3941588"/>
           </a:xfrm>
           <a:prstGeom prst="rect">
@@ -3678,7 +3679,7 @@
         <p:spPr>
           <a:xfrm>
             <a:off x="552673" y="2065201"/>
-            <a:ext cx="6059790" cy="1123384"/>
+            <a:ext cx="6059790" cy="1061829"/>
           </a:xfrm>
           <a:prstGeom prst="rect">
             <a:avLst/>
@@ -3692,36 +3693,9 @@
           <a:lstStyle/>
           <a:p>
             <a:r>
-              <a:rPr lang="en-US" sz="2800" b="1" dirty="0">
-                <a:solidFill>
-                  <a:schemeClr val="accent5"/>
-                </a:solidFill>
-                <a:effectLst>
-                  <a:outerShdw blurRad="38100" dist="38100" dir="2700000" algn="tl">
-                    <a:srgbClr val="000000">
-                      <a:alpha val="43137"/>
-                    </a:srgbClr>
-                  </a:outerShdw>
-                </a:effectLst>
-                <a:latin typeface="Californian FB" panose="0207040306080B030204" pitchFamily="18" charset="0"/>
-                <a:ea typeface="Georgia" pitchFamily="34" charset="-122"/>
-                <a:cs typeface="Georgia" pitchFamily="34" charset="-120"/>
-              </a:rPr>
-              <a:t>Smart Stock Market Analyst</a:t>
+              <a:rPr lang="en-US" sz="2400" b="1" dirty="0"/>
+              <a:t>AI STOCK PRO INTELLIGENCE</a:t>
             </a:r>
-            <a:endParaRPr lang="en-US" sz="2800" b="1" dirty="0">
-              <a:solidFill>
-                <a:schemeClr val="accent5"/>
-              </a:solidFill>
-              <a:effectLst>
-                <a:outerShdw blurRad="38100" dist="38100" dir="2700000" algn="tl">
-                  <a:srgbClr val="000000">
-                    <a:alpha val="43137"/>
-                  </a:srgbClr>
-                </a:outerShdw>
-              </a:effectLst>
-              <a:latin typeface="Californian FB" panose="0207040306080B030204" pitchFamily="18" charset="0"/>
-            </a:endParaRPr>
           </a:p>
           <a:p>
             <a:r>
@@ -3729,9 +3703,9 @@
                 <a:solidFill>
                   <a:schemeClr val="tx1"/>
                 </a:solidFill>
-                <a:latin typeface="Ink Free" panose="03080402000500000000" pitchFamily="66" charset="0"/>
+                <a:latin typeface="+mn-lt"/>
               </a:rPr>
-              <a:t>Powered by Generative AI  •  Gemini Pro  •  yFinance  •  Streamlit</a:t>
+              <a:t>     Powered by Generative AI  •  Gemini Pro  •  yFinance  •  Streamlit</a:t>
             </a:r>
           </a:p>
           <a:p>
@@ -3845,7 +3819,7 @@
         <p:spPr>
           <a:xfrm>
             <a:off x="3591976" y="4156672"/>
-            <a:ext cx="4832174" cy="1405513"/>
+            <a:ext cx="4832174" cy="1236236"/>
           </a:xfrm>
           <a:prstGeom prst="rect">
             <a:avLst/>
@@ -3858,14 +3832,154 @@
           </a:bodyPr>
           <a:lstStyle/>
           <a:p>
-            <a:pPr algn="just">
+            <a:pPr marL="171450" indent="-171450" algn="just">
               <a:spcAft>
                 <a:spcPts val="200"/>
               </a:spcAft>
               <a:buClr>
                 <a:schemeClr val="bg1"/>
               </a:buClr>
+              <a:buFont typeface="Arial" panose="020B0604020202020204" pitchFamily="34" charset="0"/>
+              <a:buChar char="•"/>
             </a:pPr>
+            <a:r>
+              <a:rPr lang="en-US" sz="1100" dirty="0">
+                <a:solidFill>
+                  <a:schemeClr val="accent6">
+                    <a:lumMod val="50000"/>
+                  </a:schemeClr>
+                </a:solidFill>
+                <a:effectLst>
+                  <a:outerShdw blurRad="38100" dist="38100" dir="2700000" algn="tl">
+                    <a:srgbClr val="000000">
+                      <a:alpha val="43137"/>
+                    </a:srgbClr>
+                  </a:outerShdw>
+                </a:effectLst>
+                <a:latin typeface="+mj-lt"/>
+              </a:rPr>
+              <a:t>Khusboo Kumari </a:t>
+            </a:r>
+          </a:p>
+          <a:p>
+            <a:pPr marL="171450" lvl="2" indent="-171450" algn="just">
+              <a:spcAft>
+                <a:spcPts val="200"/>
+              </a:spcAft>
+              <a:buClr>
+                <a:schemeClr val="bg1"/>
+              </a:buClr>
+              <a:buFont typeface="Arial" panose="020B0604020202020204" pitchFamily="34" charset="0"/>
+              <a:buChar char="•"/>
+            </a:pPr>
+            <a:r>
+              <a:rPr lang="en-US" sz="1100" dirty="0">
+                <a:solidFill>
+                  <a:schemeClr val="accent6">
+                    <a:lumMod val="50000"/>
+                  </a:schemeClr>
+                </a:solidFill>
+                <a:effectLst>
+                  <a:outerShdw blurRad="38100" dist="38100" dir="2700000" algn="tl">
+                    <a:srgbClr val="000000">
+                      <a:alpha val="43137"/>
+                    </a:srgbClr>
+                  </a:outerShdw>
+                </a:effectLst>
+                <a:latin typeface="+mj-lt"/>
+              </a:rPr>
+              <a:t>Kripita Gupta</a:t>
+            </a:r>
+          </a:p>
+          <a:p>
+            <a:pPr marL="171450" lvl="3" indent="-171450" algn="just">
+              <a:spcAft>
+                <a:spcPts val="200"/>
+              </a:spcAft>
+              <a:buClr>
+                <a:schemeClr val="bg1"/>
+              </a:buClr>
+              <a:buFont typeface="Arial" panose="020B0604020202020204" pitchFamily="34" charset="0"/>
+              <a:buChar char="•"/>
+            </a:pPr>
+            <a:r>
+              <a:rPr lang="en-US" sz="1100" dirty="0">
+                <a:solidFill>
+                  <a:schemeClr val="accent6">
+                    <a:lumMod val="50000"/>
+                  </a:schemeClr>
+                </a:solidFill>
+                <a:effectLst>
+                  <a:outerShdw blurRad="38100" dist="38100" dir="2700000" algn="tl">
+                    <a:srgbClr val="000000">
+                      <a:alpha val="43137"/>
+                    </a:srgbClr>
+                  </a:outerShdw>
+                </a:effectLst>
+                <a:latin typeface="+mj-lt"/>
+              </a:rPr>
+              <a:t>Rupam Jaiswal</a:t>
+            </a:r>
+          </a:p>
+          <a:p>
+            <a:pPr marL="171450" indent="-171450" algn="just">
+              <a:spcAft>
+                <a:spcPts val="200"/>
+              </a:spcAft>
+              <a:buClr>
+                <a:schemeClr val="bg1"/>
+              </a:buClr>
+              <a:buFont typeface="Arial" panose="020B0604020202020204" pitchFamily="34" charset="0"/>
+              <a:buChar char="•"/>
+            </a:pPr>
+            <a:r>
+              <a:rPr lang="en-US" sz="1100" dirty="0">
+                <a:solidFill>
+                  <a:schemeClr val="accent6">
+                    <a:lumMod val="50000"/>
+                  </a:schemeClr>
+                </a:solidFill>
+                <a:effectLst>
+                  <a:outerShdw blurRad="38100" dist="38100" dir="2700000" algn="tl">
+                    <a:srgbClr val="000000">
+                      <a:alpha val="43137"/>
+                    </a:srgbClr>
+                  </a:outerShdw>
+                </a:effectLst>
+                <a:latin typeface="+mj-lt"/>
+              </a:rPr>
+              <a:t>Puja Jaiswal</a:t>
+            </a:r>
+          </a:p>
+          <a:p>
+            <a:pPr marL="171450" indent="-171450" algn="just">
+              <a:spcAft>
+                <a:spcPts val="200"/>
+              </a:spcAft>
+              <a:buClr>
+                <a:schemeClr val="bg1"/>
+              </a:buClr>
+              <a:buFont typeface="Arial" panose="020B0604020202020204" pitchFamily="34" charset="0"/>
+              <a:buChar char="•"/>
+            </a:pPr>
+            <a:r>
+              <a:rPr lang="en-US" sz="1100" dirty="0">
+                <a:solidFill>
+                  <a:schemeClr val="accent6">
+                    <a:lumMod val="50000"/>
+                  </a:schemeClr>
+                </a:solidFill>
+                <a:effectLst>
+                  <a:outerShdw blurRad="38100" dist="38100" dir="2700000" algn="tl">
+                    <a:srgbClr val="000000">
+                      <a:alpha val="43137"/>
+                    </a:srgbClr>
+                  </a:outerShdw>
+                </a:effectLst>
+                <a:latin typeface="+mj-lt"/>
+              </a:rPr>
+              <a:t>Md Ali Sher</a:t>
+            </a:r>
             <a:r>
               <a:rPr lang="en-US" sz="1100" dirty="0">
                 <a:solidFill>
@@ -3882,119 +3996,7 @@
                 </a:effectLst>
                 <a:latin typeface="Cooper Black" panose="0208090404030B020404" pitchFamily="18" charset="0"/>
               </a:rPr>
-              <a:t>       Khusboo Kumari </a:t>
-            </a:r>
-          </a:p>
-          <a:p>
-            <a:pPr lvl="2" algn="just">
-              <a:spcAft>
-                <a:spcPts val="200"/>
-              </a:spcAft>
-              <a:buClr>
-                <a:schemeClr val="bg1"/>
-              </a:buClr>
-            </a:pPr>
-            <a:r>
-              <a:rPr lang="en-US" sz="1100" dirty="0">
-                <a:solidFill>
-                  <a:schemeClr val="accent4">
-                    <a:lumMod val="75000"/>
-                  </a:schemeClr>
-                </a:solidFill>
-                <a:effectLst>
-                  <a:outerShdw blurRad="38100" dist="38100" dir="2700000" algn="tl">
-                    <a:srgbClr val="000000">
-                      <a:alpha val="43137"/>
-                    </a:srgbClr>
-                  </a:outerShdw>
-                </a:effectLst>
-                <a:latin typeface="Cooper Black" panose="0208090404030B020404" pitchFamily="18" charset="0"/>
-              </a:rPr>
-              <a:t>                                              Kripita Gupta</a:t>
-            </a:r>
-          </a:p>
-          <a:p>
-            <a:pPr lvl="3" algn="just">
-              <a:spcAft>
-                <a:spcPts val="200"/>
-              </a:spcAft>
-              <a:buClr>
-                <a:schemeClr val="bg1"/>
-              </a:buClr>
-            </a:pPr>
-            <a:r>
-              <a:rPr lang="en-US" sz="1100" dirty="0">
-                <a:solidFill>
-                  <a:schemeClr val="accent4">
-                    <a:lumMod val="75000"/>
-                  </a:schemeClr>
-                </a:solidFill>
-                <a:effectLst>
-                  <a:outerShdw blurRad="38100" dist="38100" dir="2700000" algn="tl">
-                    <a:srgbClr val="000000">
-                      <a:alpha val="43137"/>
-                    </a:srgbClr>
-                  </a:outerShdw>
-                </a:effectLst>
-                <a:latin typeface="Cooper Black" panose="0208090404030B020404" pitchFamily="18" charset="0"/>
-              </a:rPr>
-              <a:t>                                                                                      Rupam Jaiswal</a:t>
-            </a:r>
-          </a:p>
-          <a:p>
-            <a:pPr algn="just">
-              <a:spcAft>
-                <a:spcPts val="200"/>
-              </a:spcAft>
-              <a:buClr>
-                <a:schemeClr val="bg1"/>
-              </a:buClr>
-            </a:pPr>
-            <a:r>
-              <a:rPr lang="en-US" sz="1100" dirty="0">
-                <a:solidFill>
-                  <a:schemeClr val="accent4">
-                    <a:lumMod val="75000"/>
-                  </a:schemeClr>
-                </a:solidFill>
-                <a:effectLst>
-                  <a:outerShdw blurRad="38100" dist="38100" dir="2700000" algn="tl">
-                    <a:srgbClr val="000000">
-                      <a:alpha val="43137"/>
-                    </a:srgbClr>
-                  </a:outerShdw>
-                </a:effectLst>
-                <a:latin typeface="Cooper Black" panose="0208090404030B020404" pitchFamily="18" charset="0"/>
-              </a:rPr>
-              <a:t>                        Puja Jaiswal</a:t>
-            </a:r>
-          </a:p>
-          <a:p>
-            <a:pPr algn="just">
-              <a:spcAft>
-                <a:spcPts val="200"/>
-              </a:spcAft>
-              <a:buClr>
-                <a:schemeClr val="bg1"/>
-              </a:buClr>
-            </a:pPr>
-            <a:r>
-              <a:rPr lang="en-US" sz="1100" dirty="0">
-                <a:solidFill>
-                  <a:schemeClr val="accent4">
-                    <a:lumMod val="75000"/>
-                  </a:schemeClr>
-                </a:solidFill>
-                <a:effectLst>
-                  <a:outerShdw blurRad="38100" dist="38100" dir="2700000" algn="tl">
-                    <a:srgbClr val="000000">
-                      <a:alpha val="43137"/>
-                    </a:srgbClr>
-                  </a:outerShdw>
-                </a:effectLst>
-                <a:latin typeface="Cooper Black" panose="0208090404030B020404" pitchFamily="18" charset="0"/>
-              </a:rPr>
-              <a:t>                                                                                                          Md Ali Sher </a:t>
+              <a:t> </a:t>
             </a:r>
             <a:r>
               <a:rPr lang="en-US" sz="1100" dirty="0">
@@ -4216,36 +4218,6 @@
           </p:spPr>
         </p:pic>
       </p:grpSp>
-      <p:pic>
-        <p:nvPicPr>
-          <p:cNvPr id="4" name="Image 0" descr="preencoded.png">
-            <a:extLst>
-              <a:ext uri="{FF2B5EF4-FFF2-40B4-BE49-F238E27FC236}">
-                <a16:creationId xmlns:a16="http://schemas.microsoft.com/office/drawing/2014/main" id="{BB0368CE-8B80-49BB-887D-5B48304E3A2E}"/>
-              </a:ext>
-            </a:extLst>
-          </p:cNvPr>
-          <p:cNvPicPr>
-            <a:picLocks noChangeAspect="1"/>
-          </p:cNvPicPr>
-          <p:nvPr/>
-        </p:nvPicPr>
-        <p:blipFill>
-          <a:blip r:embed="rId10"/>
-          <a:stretch>
-            <a:fillRect/>
-          </a:stretch>
-        </p:blipFill>
-        <p:spPr>
-          <a:xfrm>
-            <a:off x="1220370" y="3937596"/>
-            <a:ext cx="1280160" cy="1280160"/>
-          </a:xfrm>
-          <a:prstGeom prst="rect">
-            <a:avLst/>
-          </a:prstGeom>
-        </p:spPr>
-      </p:pic>
     </p:spTree>
   </p:cSld>
   <p:clrMapOvr>
@@ -4275,7 +4247,7 @@
                             </p:stCondLst>
                             <p:childTnLst>
                               <p:par>
-                                <p:cTn id="5" presetID="2" presetClass="entr" presetSubtype="4" fill="hold" nodeType="clickEffect">
+                                <p:cTn id="5" presetID="21" presetClass="entr" presetSubtype="1" fill="hold" nodeType="clickEffect">
                                   <p:stCondLst>
                                     <p:cond delay="0"/>
                                   </p:stCondLst>
@@ -4302,116 +4274,13 @@
                                         <p:strVal val="visible"/>
                                       </p:to>
                                     </p:set>
-                                    <p:anim calcmode="lin" valueType="num">
-                                      <p:cBhvr additive="base">
-                                        <p:cTn id="7" dur="500" fill="hold"/>
+                                    <p:animEffect transition="in" filter="wheel(1)">
+                                      <p:cBhvr>
+                                        <p:cTn id="7" dur="2000"/>
                                         <p:tgtEl>
                                           <p:spTgt spid="35">
                                             <p:txEl>
                                               <p:pRg st="0" end="0"/>
-                                            </p:txEl>
-                                          </p:spTgt>
-                                        </p:tgtEl>
-                                        <p:attrNameLst>
-                                          <p:attrName>ppt_x</p:attrName>
-                                        </p:attrNameLst>
-                                      </p:cBhvr>
-                                      <p:tavLst>
-                                        <p:tav tm="0">
-                                          <p:val>
-                                            <p:strVal val="#ppt_x"/>
-                                          </p:val>
-                                        </p:tav>
-                                        <p:tav tm="100000">
-                                          <p:val>
-                                            <p:strVal val="#ppt_x"/>
-                                          </p:val>
-                                        </p:tav>
-                                      </p:tavLst>
-                                    </p:anim>
-                                    <p:anim calcmode="lin" valueType="num">
-                                      <p:cBhvr additive="base">
-                                        <p:cTn id="8" dur="500" fill="hold"/>
-                                        <p:tgtEl>
-                                          <p:spTgt spid="35">
-                                            <p:txEl>
-                                              <p:pRg st="0" end="0"/>
-                                            </p:txEl>
-                                          </p:spTgt>
-                                        </p:tgtEl>
-                                        <p:attrNameLst>
-                                          <p:attrName>ppt_y</p:attrName>
-                                        </p:attrNameLst>
-                                      </p:cBhvr>
-                                      <p:tavLst>
-                                        <p:tav tm="0">
-                                          <p:val>
-                                            <p:strVal val="1+#ppt_h/2"/>
-                                          </p:val>
-                                        </p:tav>
-                                        <p:tav tm="100000">
-                                          <p:val>
-                                            <p:strVal val="#ppt_y"/>
-                                          </p:val>
-                                        </p:tav>
-                                      </p:tavLst>
-                                    </p:anim>
-                                  </p:childTnLst>
-                                </p:cTn>
-                              </p:par>
-                            </p:childTnLst>
-                          </p:cTn>
-                        </p:par>
-                      </p:childTnLst>
-                    </p:cTn>
-                  </p:par>
-                  <p:par>
-                    <p:cTn id="9" fill="hold">
-                      <p:stCondLst>
-                        <p:cond delay="indefinite"/>
-                      </p:stCondLst>
-                      <p:childTnLst>
-                        <p:par>
-                          <p:cTn id="10" fill="hold">
-                            <p:stCondLst>
-                              <p:cond delay="0"/>
-                            </p:stCondLst>
-                            <p:childTnLst>
-                              <p:par>
-                                <p:cTn id="11" presetID="21" presetClass="entr" presetSubtype="1" fill="hold" nodeType="clickEffect">
-                                  <p:stCondLst>
-                                    <p:cond delay="0"/>
-                                  </p:stCondLst>
-                                  <p:childTnLst>
-                                    <p:set>
-                                      <p:cBhvr>
-                                        <p:cTn id="12" dur="1" fill="hold">
-                                          <p:stCondLst>
-                                            <p:cond delay="0"/>
-                                          </p:stCondLst>
-                                        </p:cTn>
-                                        <p:tgtEl>
-                                          <p:spTgt spid="35">
-                                            <p:txEl>
-                                              <p:pRg st="1" end="1"/>
-                                            </p:txEl>
-                                          </p:spTgt>
-                                        </p:tgtEl>
-                                        <p:attrNameLst>
-                                          <p:attrName>style.visibility</p:attrName>
-                                        </p:attrNameLst>
-                                      </p:cBhvr>
-                                      <p:to>
-                                        <p:strVal val="visible"/>
-                                      </p:to>
-                                    </p:set>
-                                    <p:animEffect transition="in" filter="wheel(1)">
-                                      <p:cBhvr>
-                                        <p:cTn id="13" dur="2000"/>
-                                        <p:tgtEl>
-                                          <p:spTgt spid="35">
-                                            <p:txEl>
-                                              <p:pRg st="1" end="1"/>
                                             </p:txEl>
                                           </p:spTgt>
                                         </p:tgtEl>
@@ -4427,32 +4296,36 @@
                     </p:cTn>
                   </p:par>
                   <p:par>
-                    <p:cTn id="14" fill="hold">
+                    <p:cTn id="8" fill="hold">
                       <p:stCondLst>
                         <p:cond delay="indefinite"/>
                       </p:stCondLst>
                       <p:childTnLst>
                         <p:par>
-                          <p:cTn id="15" fill="hold">
+                          <p:cTn id="9" fill="hold">
                             <p:stCondLst>
                               <p:cond delay="0"/>
                             </p:stCondLst>
                             <p:childTnLst>
                               <p:par>
-                                <p:cTn id="16" presetID="16" presetClass="entr" presetSubtype="21" fill="hold" grpId="0" nodeType="clickEffect">
+                                <p:cTn id="10" presetID="21" presetClass="entr" presetSubtype="1" fill="hold" nodeType="clickEffect">
                                   <p:stCondLst>
                                     <p:cond delay="0"/>
                                   </p:stCondLst>
                                   <p:childTnLst>
                                     <p:set>
                                       <p:cBhvr>
-                                        <p:cTn id="17" dur="1" fill="hold">
+                                        <p:cTn id="11" dur="1" fill="hold">
                                           <p:stCondLst>
                                             <p:cond delay="0"/>
                                           </p:stCondLst>
                                         </p:cTn>
                                         <p:tgtEl>
-                                          <p:spTgt spid="40"/>
+                                          <p:spTgt spid="35">
+                                            <p:txEl>
+                                              <p:pRg st="1" end="1"/>
+                                            </p:txEl>
+                                          </p:spTgt>
                                         </p:tgtEl>
                                         <p:attrNameLst>
                                           <p:attrName>style.visibility</p:attrName>
@@ -4462,11 +4335,15 @@
                                         <p:strVal val="visible"/>
                                       </p:to>
                                     </p:set>
-                                    <p:animEffect transition="in" filter="barn(inVertical)">
-                                      <p:cBhvr>
-                                        <p:cTn id="18" dur="500"/>
-                                        <p:tgtEl>
-                                          <p:spTgt spid="40"/>
+                                    <p:animEffect transition="in" filter="wheel(1)">
+                                      <p:cBhvr>
+                                        <p:cTn id="12" dur="2000"/>
+                                        <p:tgtEl>
+                                          <p:spTgt spid="35">
+                                            <p:txEl>
+                                              <p:pRg st="1" end="1"/>
+                                            </p:txEl>
+                                          </p:spTgt>
                                         </p:tgtEl>
                                       </p:cBhvr>
                                     </p:animEffect>
@@ -4480,36 +4357,32 @@
                     </p:cTn>
                   </p:par>
                   <p:par>
-                    <p:cTn id="19" fill="hold">
+                    <p:cTn id="13" fill="hold">
                       <p:stCondLst>
                         <p:cond delay="indefinite"/>
                       </p:stCondLst>
                       <p:childTnLst>
                         <p:par>
-                          <p:cTn id="20" fill="hold">
+                          <p:cTn id="14" fill="hold">
                             <p:stCondLst>
                               <p:cond delay="0"/>
                             </p:stCondLst>
                             <p:childTnLst>
                               <p:par>
-                                <p:cTn id="21" presetID="16" presetClass="entr" presetSubtype="21" fill="hold" nodeType="clickEffect">
+                                <p:cTn id="15" presetID="16" presetClass="entr" presetSubtype="21" fill="hold" grpId="0" nodeType="clickEffect">
                                   <p:stCondLst>
                                     <p:cond delay="0"/>
                                   </p:stCondLst>
                                   <p:childTnLst>
                                     <p:set>
                                       <p:cBhvr>
-                                        <p:cTn id="22" dur="1" fill="hold">
+                                        <p:cTn id="16" dur="1" fill="hold">
                                           <p:stCondLst>
                                             <p:cond delay="0"/>
                                           </p:stCondLst>
                                         </p:cTn>
                                         <p:tgtEl>
-                                          <p:spTgt spid="41">
-                                            <p:txEl>
-                                              <p:pRg st="0" end="0"/>
-                                            </p:txEl>
-                                          </p:spTgt>
+                                          <p:spTgt spid="40"/>
                                         </p:tgtEl>
                                         <p:attrNameLst>
                                           <p:attrName>style.visibility</p:attrName>
@@ -4521,13 +4394,9 @@
                                     </p:set>
                                     <p:animEffect transition="in" filter="barn(inVertical)">
                                       <p:cBhvr>
-                                        <p:cTn id="23" dur="500"/>
-                                        <p:tgtEl>
-                                          <p:spTgt spid="41">
-                                            <p:txEl>
-                                              <p:pRg st="0" end="0"/>
-                                            </p:txEl>
-                                          </p:spTgt>
+                                        <p:cTn id="17" dur="500"/>
+                                        <p:tgtEl>
+                                          <p:spTgt spid="40"/>
                                         </p:tgtEl>
                                       </p:cBhvr>
                                     </p:animEffect>
@@ -4541,26 +4410,26 @@
                     </p:cTn>
                   </p:par>
                   <p:par>
-                    <p:cTn id="24" fill="hold">
+                    <p:cTn id="18" fill="hold">
                       <p:stCondLst>
                         <p:cond delay="indefinite"/>
                       </p:stCondLst>
                       <p:childTnLst>
                         <p:par>
-                          <p:cTn id="25" fill="hold">
+                          <p:cTn id="19" fill="hold">
                             <p:stCondLst>
                               <p:cond delay="0"/>
                             </p:stCondLst>
                             <p:childTnLst>
                               <p:par>
-                                <p:cTn id="26" presetID="16" presetClass="entr" presetSubtype="21" fill="hold" nodeType="clickEffect">
+                                <p:cTn id="20" presetID="16" presetClass="entr" presetSubtype="21" fill="hold" nodeType="clickEffect">
                                   <p:stCondLst>
                                     <p:cond delay="0"/>
                                   </p:stCondLst>
                                   <p:childTnLst>
                                     <p:set>
                                       <p:cBhvr>
-                                        <p:cTn id="27" dur="1" fill="hold">
+                                        <p:cTn id="21" dur="1" fill="hold">
                                           <p:stCondLst>
                                             <p:cond delay="0"/>
                                           </p:stCondLst>
@@ -4568,7 +4437,7 @@
                                         <p:tgtEl>
                                           <p:spTgt spid="41">
                                             <p:txEl>
-                                              <p:pRg st="1" end="1"/>
+                                              <p:pRg st="0" end="0"/>
                                             </p:txEl>
                                           </p:spTgt>
                                         </p:tgtEl>
@@ -4582,11 +4451,11 @@
                                     </p:set>
                                     <p:animEffect transition="in" filter="barn(inVertical)">
                                       <p:cBhvr>
-                                        <p:cTn id="28" dur="500"/>
+                                        <p:cTn id="22" dur="500"/>
                                         <p:tgtEl>
                                           <p:spTgt spid="41">
                                             <p:txEl>
-                                              <p:pRg st="1" end="1"/>
+                                              <p:pRg st="0" end="0"/>
                                             </p:txEl>
                                           </p:spTgt>
                                         </p:tgtEl>
@@ -4602,26 +4471,26 @@
                     </p:cTn>
                   </p:par>
                   <p:par>
-                    <p:cTn id="29" fill="hold">
+                    <p:cTn id="23" fill="hold">
                       <p:stCondLst>
                         <p:cond delay="indefinite"/>
                       </p:stCondLst>
                       <p:childTnLst>
                         <p:par>
-                          <p:cTn id="30" fill="hold">
+                          <p:cTn id="24" fill="hold">
                             <p:stCondLst>
                               <p:cond delay="0"/>
                             </p:stCondLst>
                             <p:childTnLst>
                               <p:par>
-                                <p:cTn id="31" presetID="16" presetClass="entr" presetSubtype="21" fill="hold" nodeType="clickEffect">
+                                <p:cTn id="25" presetID="16" presetClass="entr" presetSubtype="21" fill="hold" nodeType="clickEffect">
                                   <p:stCondLst>
                                     <p:cond delay="0"/>
                                   </p:stCondLst>
                                   <p:childTnLst>
                                     <p:set>
                                       <p:cBhvr>
-                                        <p:cTn id="32" dur="1" fill="hold">
+                                        <p:cTn id="26" dur="1" fill="hold">
                                           <p:stCondLst>
                                             <p:cond delay="0"/>
                                           </p:stCondLst>
@@ -4629,7 +4498,7 @@
                                         <p:tgtEl>
                                           <p:spTgt spid="41">
                                             <p:txEl>
-                                              <p:pRg st="3" end="3"/>
+                                              <p:pRg st="1" end="1"/>
                                             </p:txEl>
                                           </p:spTgt>
                                         </p:tgtEl>
@@ -4643,11 +4512,11 @@
                                     </p:set>
                                     <p:animEffect transition="in" filter="barn(inVertical)">
                                       <p:cBhvr>
-                                        <p:cTn id="33" dur="500"/>
+                                        <p:cTn id="27" dur="500"/>
                                         <p:tgtEl>
                                           <p:spTgt spid="41">
                                             <p:txEl>
-                                              <p:pRg st="3" end="3"/>
+                                              <p:pRg st="1" end="1"/>
                                             </p:txEl>
                                           </p:spTgt>
                                         </p:tgtEl>
@@ -4663,26 +4532,26 @@
                     </p:cTn>
                   </p:par>
                   <p:par>
-                    <p:cTn id="34" fill="hold">
+                    <p:cTn id="28" fill="hold">
                       <p:stCondLst>
                         <p:cond delay="indefinite"/>
                       </p:stCondLst>
                       <p:childTnLst>
                         <p:par>
-                          <p:cTn id="35" fill="hold">
+                          <p:cTn id="29" fill="hold">
                             <p:stCondLst>
                               <p:cond delay="0"/>
                             </p:stCondLst>
                             <p:childTnLst>
                               <p:par>
-                                <p:cTn id="36" presetID="16" presetClass="entr" presetSubtype="21" fill="hold" nodeType="clickEffect">
+                                <p:cTn id="30" presetID="16" presetClass="entr" presetSubtype="21" fill="hold" nodeType="clickEffect">
                                   <p:stCondLst>
                                     <p:cond delay="0"/>
                                   </p:stCondLst>
                                   <p:childTnLst>
                                     <p:set>
                                       <p:cBhvr>
-                                        <p:cTn id="37" dur="1" fill="hold">
+                                        <p:cTn id="31" dur="1" fill="hold">
                                           <p:stCondLst>
                                             <p:cond delay="0"/>
                                           </p:stCondLst>
@@ -4690,7 +4559,7 @@
                                         <p:tgtEl>
                                           <p:spTgt spid="41">
                                             <p:txEl>
-                                              <p:pRg st="2" end="2"/>
+                                              <p:pRg st="3" end="3"/>
                                             </p:txEl>
                                           </p:spTgt>
                                         </p:tgtEl>
@@ -4704,11 +4573,11 @@
                                     </p:set>
                                     <p:animEffect transition="in" filter="barn(inVertical)">
                                       <p:cBhvr>
-                                        <p:cTn id="38" dur="500"/>
+                                        <p:cTn id="32" dur="500"/>
                                         <p:tgtEl>
                                           <p:spTgt spid="41">
                                             <p:txEl>
-                                              <p:pRg st="2" end="2"/>
+                                              <p:pRg st="3" end="3"/>
                                             </p:txEl>
                                           </p:spTgt>
                                         </p:tgtEl>
@@ -4724,26 +4593,26 @@
                     </p:cTn>
                   </p:par>
                   <p:par>
-                    <p:cTn id="39" fill="hold">
+                    <p:cTn id="33" fill="hold">
                       <p:stCondLst>
                         <p:cond delay="indefinite"/>
                       </p:stCondLst>
                       <p:childTnLst>
                         <p:par>
-                          <p:cTn id="40" fill="hold">
+                          <p:cTn id="34" fill="hold">
                             <p:stCondLst>
                               <p:cond delay="0"/>
                             </p:stCondLst>
                             <p:childTnLst>
                               <p:par>
-                                <p:cTn id="41" presetID="16" presetClass="entr" presetSubtype="21" fill="hold" nodeType="clickEffect">
+                                <p:cTn id="35" presetID="16" presetClass="entr" presetSubtype="21" fill="hold" nodeType="clickEffect">
                                   <p:stCondLst>
                                     <p:cond delay="0"/>
                                   </p:stCondLst>
                                   <p:childTnLst>
                                     <p:set>
                                       <p:cBhvr>
-                                        <p:cTn id="42" dur="1" fill="hold">
+                                        <p:cTn id="36" dur="1" fill="hold">
                                           <p:stCondLst>
                                             <p:cond delay="0"/>
                                           </p:stCondLst>
@@ -4751,7 +4620,7 @@
                                         <p:tgtEl>
                                           <p:spTgt spid="41">
                                             <p:txEl>
-                                              <p:pRg st="4" end="4"/>
+                                              <p:pRg st="2" end="2"/>
                                             </p:txEl>
                                           </p:spTgt>
                                         </p:tgtEl>
@@ -4765,7 +4634,68 @@
                                     </p:set>
                                     <p:animEffect transition="in" filter="barn(inVertical)">
                                       <p:cBhvr>
-                                        <p:cTn id="43" dur="500"/>
+                                        <p:cTn id="37" dur="500"/>
+                                        <p:tgtEl>
+                                          <p:spTgt spid="41">
+                                            <p:txEl>
+                                              <p:pRg st="2" end="2"/>
+                                            </p:txEl>
+                                          </p:spTgt>
+                                        </p:tgtEl>
+                                      </p:cBhvr>
+                                    </p:animEffect>
+                                  </p:childTnLst>
+                                </p:cTn>
+                              </p:par>
+                            </p:childTnLst>
+                          </p:cTn>
+                        </p:par>
+                      </p:childTnLst>
+                    </p:cTn>
+                  </p:par>
+                  <p:par>
+                    <p:cTn id="38" fill="hold">
+                      <p:stCondLst>
+                        <p:cond delay="indefinite"/>
+                      </p:stCondLst>
+                      <p:childTnLst>
+                        <p:par>
+                          <p:cTn id="39" fill="hold">
+                            <p:stCondLst>
+                              <p:cond delay="0"/>
+                            </p:stCondLst>
+                            <p:childTnLst>
+                              <p:par>
+                                <p:cTn id="40" presetID="16" presetClass="entr" presetSubtype="21" fill="hold" nodeType="clickEffect">
+                                  <p:stCondLst>
+                                    <p:cond delay="0"/>
+                                  </p:stCondLst>
+                                  <p:childTnLst>
+                                    <p:set>
+                                      <p:cBhvr>
+                                        <p:cTn id="41" dur="1" fill="hold">
+                                          <p:stCondLst>
+                                            <p:cond delay="0"/>
+                                          </p:stCondLst>
+                                        </p:cTn>
+                                        <p:tgtEl>
+                                          <p:spTgt spid="41">
+                                            <p:txEl>
+                                              <p:pRg st="4" end="4"/>
+                                            </p:txEl>
+                                          </p:spTgt>
+                                        </p:tgtEl>
+                                        <p:attrNameLst>
+                                          <p:attrName>style.visibility</p:attrName>
+                                        </p:attrNameLst>
+                                      </p:cBhvr>
+                                      <p:to>
+                                        <p:strVal val="visible"/>
+                                      </p:to>
+                                    </p:set>
+                                    <p:animEffect transition="in" filter="barn(inVertical)">
+                                      <p:cBhvr>
+                                        <p:cTn id="42" dur="500"/>
                                         <p:tgtEl>
                                           <p:spTgt spid="41">
                                             <p:txEl>
@@ -4888,7 +4818,7 @@
         <p:spPr>
           <a:xfrm>
             <a:off x="40654" y="526852"/>
-            <a:ext cx="5406254" cy="4308872"/>
+            <a:ext cx="5406254" cy="4678204"/>
           </a:xfrm>
           <a:prstGeom prst="rect">
             <a:avLst/>
@@ -4952,6 +4882,9 @@
             </a:r>
           </a:p>
           <a:p>
+            <a:endParaRPr lang="en-US" sz="1200" dirty="0"/>
+          </a:p>
+          <a:p>
             <a:r>
               <a:rPr lang="en-US" sz="1200" b="1" dirty="0"/>
               <a:t>Sentiment Analysis:</a:t>
@@ -4984,6 +4917,9 @@
               <a:rPr lang="en-US" sz="1200" dirty="0"/>
               <a:t>.</a:t>
             </a:r>
+          </a:p>
+          <a:p>
+            <a:endParaRPr lang="en-US" sz="1200" dirty="0"/>
           </a:p>
           <a:p>
             <a:r>
@@ -5111,13 +5047,13 @@
   <p:clrMapOvr>
     <a:masterClrMapping/>
   </p:clrMapOvr>
-  <mc:AlternateContent xmlns:mc="http://schemas.openxmlformats.org/markup-compatibility/2006">
-    <mc:Choice xmlns:p159="http://schemas.microsoft.com/office/powerpoint/2015/09/main" Requires="p159">
+  <mc:AlternateContent xmlns:mc="http://schemas.openxmlformats.org/markup-compatibility/2006" xmlns:p159="http://schemas.microsoft.com/office/powerpoint/2015/09/main">
+    <mc:Choice Requires="p159">
       <p:transition xmlns:p14="http://schemas.microsoft.com/office/powerpoint/2010/main" spd="slow" p14:dur="2000">
         <p159:morph option="byObject"/>
       </p:transition>
     </mc:Choice>
-    <mc:Fallback>
+    <mc:Fallback xmlns="">
       <p:transition spd="slow">
         <p:fade/>
       </p:transition>
@@ -6940,7 +6876,7 @@
                                         <p:tgtEl>
                                           <p:spTgt spid="6">
                                             <p:txEl>
-                                              <p:pRg st="8" end="8"/>
+                                              <p:pRg st="9" end="9"/>
                                             </p:txEl>
                                           </p:spTgt>
                                         </p:tgtEl>
@@ -6962,7 +6898,7 @@
                                         <p:tgtEl>
                                           <p:spTgt spid="6">
                                             <p:txEl>
-                                              <p:pRg st="8" end="8"/>
+                                              <p:pRg st="9" end="9"/>
                                             </p:txEl>
                                           </p:spTgt>
                                         </p:tgtEl>
@@ -6978,7 +6914,7 @@
                                         <p:tgtEl>
                                           <p:spTgt spid="6">
                                             <p:txEl>
-                                              <p:pRg st="8" end="8"/>
+                                              <p:pRg st="9" end="9"/>
                                             </p:txEl>
                                           </p:spTgt>
                                         </p:tgtEl>
@@ -7009,7 +6945,7 @@
                                         <p:tgtEl>
                                           <p:spTgt spid="6">
                                             <p:txEl>
-                                              <p:pRg st="8" end="8"/>
+                                              <p:pRg st="9" end="9"/>
                                             </p:txEl>
                                           </p:spTgt>
                                         </p:tgtEl>
@@ -7040,7 +6976,7 @@
                                         <p:tgtEl>
                                           <p:spTgt spid="6">
                                             <p:txEl>
-                                              <p:pRg st="8" end="8"/>
+                                              <p:pRg st="9" end="9"/>
                                             </p:txEl>
                                           </p:spTgt>
                                         </p:tgtEl>
@@ -7071,7 +7007,7 @@
                                         <p:tgtEl>
                                           <p:spTgt spid="6">
                                             <p:txEl>
-                                              <p:pRg st="8" end="8"/>
+                                              <p:pRg st="9" end="9"/>
                                             </p:txEl>
                                           </p:spTgt>
                                         </p:tgtEl>
@@ -7102,7 +7038,7 @@
                                         <p:tgtEl>
                                           <p:spTgt spid="6">
                                             <p:txEl>
-                                              <p:pRg st="8" end="8"/>
+                                              <p:pRg st="9" end="9"/>
                                             </p:txEl>
                                           </p:spTgt>
                                         </p:tgtEl>
@@ -7133,7 +7069,7 @@
                                         <p:tgtEl>
                                           <p:spTgt spid="6">
                                             <p:txEl>
-                                              <p:pRg st="8" end="8"/>
+                                              <p:pRg st="9" end="9"/>
                                             </p:txEl>
                                           </p:spTgt>
                                         </p:tgtEl>
@@ -7150,7 +7086,7 @@
                                         <p:tgtEl>
                                           <p:spTgt spid="6">
                                             <p:txEl>
-                                              <p:pRg st="8" end="8"/>
+                                              <p:pRg st="9" end="9"/>
                                             </p:txEl>
                                           </p:spTgt>
                                         </p:tgtEl>
@@ -7167,7 +7103,7 @@
                                         <p:tgtEl>
                                           <p:spTgt spid="6">
                                             <p:txEl>
-                                              <p:pRg st="8" end="8"/>
+                                              <p:pRg st="9" end="9"/>
                                             </p:txEl>
                                           </p:spTgt>
                                         </p:tgtEl>
@@ -7184,7 +7120,7 @@
                                         <p:tgtEl>
                                           <p:spTgt spid="6">
                                             <p:txEl>
-                                              <p:pRg st="8" end="8"/>
+                                              <p:pRg st="9" end="9"/>
                                             </p:txEl>
                                           </p:spTgt>
                                         </p:tgtEl>
@@ -7201,7 +7137,7 @@
                                         <p:tgtEl>
                                           <p:spTgt spid="6">
                                             <p:txEl>
-                                              <p:pRg st="8" end="8"/>
+                                              <p:pRg st="9" end="9"/>
                                             </p:txEl>
                                           </p:spTgt>
                                         </p:tgtEl>
@@ -7218,7 +7154,7 @@
                                         <p:tgtEl>
                                           <p:spTgt spid="6">
                                             <p:txEl>
-                                              <p:pRg st="8" end="8"/>
+                                              <p:pRg st="9" end="9"/>
                                             </p:txEl>
                                           </p:spTgt>
                                         </p:tgtEl>
@@ -7235,7 +7171,7 @@
                                         <p:tgtEl>
                                           <p:spTgt spid="6">
                                             <p:txEl>
-                                              <p:pRg st="8" end="8"/>
+                                              <p:pRg st="9" end="9"/>
                                             </p:txEl>
                                           </p:spTgt>
                                         </p:tgtEl>
@@ -7252,7 +7188,7 @@
                                         <p:tgtEl>
                                           <p:spTgt spid="6">
                                             <p:txEl>
-                                              <p:pRg st="8" end="8"/>
+                                              <p:pRg st="9" end="9"/>
                                             </p:txEl>
                                           </p:spTgt>
                                         </p:tgtEl>
@@ -7278,7 +7214,7 @@
                                         <p:tgtEl>
                                           <p:spTgt spid="6">
                                             <p:txEl>
-                                              <p:pRg st="9" end="9"/>
+                                              <p:pRg st="11" end="11"/>
                                             </p:txEl>
                                           </p:spTgt>
                                         </p:tgtEl>
@@ -7300,7 +7236,7 @@
                                         <p:tgtEl>
                                           <p:spTgt spid="6">
                                             <p:txEl>
-                                              <p:pRg st="9" end="9"/>
+                                              <p:pRg st="11" end="11"/>
                                             </p:txEl>
                                           </p:spTgt>
                                         </p:tgtEl>
@@ -7316,7 +7252,7 @@
                                         <p:tgtEl>
                                           <p:spTgt spid="6">
                                             <p:txEl>
-                                              <p:pRg st="9" end="9"/>
+                                              <p:pRg st="11" end="11"/>
                                             </p:txEl>
                                           </p:spTgt>
                                         </p:tgtEl>
@@ -7347,7 +7283,7 @@
                                         <p:tgtEl>
                                           <p:spTgt spid="6">
                                             <p:txEl>
-                                              <p:pRg st="9" end="9"/>
+                                              <p:pRg st="11" end="11"/>
                                             </p:txEl>
                                           </p:spTgt>
                                         </p:tgtEl>
@@ -7378,7 +7314,7 @@
                                         <p:tgtEl>
                                           <p:spTgt spid="6">
                                             <p:txEl>
-                                              <p:pRg st="9" end="9"/>
+                                              <p:pRg st="11" end="11"/>
                                             </p:txEl>
                                           </p:spTgt>
                                         </p:tgtEl>
@@ -7409,7 +7345,7 @@
                                         <p:tgtEl>
                                           <p:spTgt spid="6">
                                             <p:txEl>
-                                              <p:pRg st="9" end="9"/>
+                                              <p:pRg st="11" end="11"/>
                                             </p:txEl>
                                           </p:spTgt>
                                         </p:tgtEl>
@@ -7440,7 +7376,7 @@
                                         <p:tgtEl>
                                           <p:spTgt spid="6">
                                             <p:txEl>
-                                              <p:pRg st="9" end="9"/>
+                                              <p:pRg st="11" end="11"/>
                                             </p:txEl>
                                           </p:spTgt>
                                         </p:tgtEl>
@@ -7471,7 +7407,7 @@
                                         <p:tgtEl>
                                           <p:spTgt spid="6">
                                             <p:txEl>
-                                              <p:pRg st="9" end="9"/>
+                                              <p:pRg st="11" end="11"/>
                                             </p:txEl>
                                           </p:spTgt>
                                         </p:tgtEl>
@@ -7488,7 +7424,7 @@
                                         <p:tgtEl>
                                           <p:spTgt spid="6">
                                             <p:txEl>
-                                              <p:pRg st="9" end="9"/>
+                                              <p:pRg st="11" end="11"/>
                                             </p:txEl>
                                           </p:spTgt>
                                         </p:tgtEl>
@@ -7505,7 +7441,7 @@
                                         <p:tgtEl>
                                           <p:spTgt spid="6">
                                             <p:txEl>
-                                              <p:pRg st="9" end="9"/>
+                                              <p:pRg st="11" end="11"/>
                                             </p:txEl>
                                           </p:spTgt>
                                         </p:tgtEl>
@@ -7522,7 +7458,7 @@
                                         <p:tgtEl>
                                           <p:spTgt spid="6">
                                             <p:txEl>
-                                              <p:pRg st="9" end="9"/>
+                                              <p:pRg st="11" end="11"/>
                                             </p:txEl>
                                           </p:spTgt>
                                         </p:tgtEl>
@@ -7539,7 +7475,7 @@
                                         <p:tgtEl>
                                           <p:spTgt spid="6">
                                             <p:txEl>
-                                              <p:pRg st="9" end="9"/>
+                                              <p:pRg st="11" end="11"/>
                                             </p:txEl>
                                           </p:spTgt>
                                         </p:tgtEl>
@@ -7556,7 +7492,7 @@
                                         <p:tgtEl>
                                           <p:spTgt spid="6">
                                             <p:txEl>
-                                              <p:pRg st="9" end="9"/>
+                                              <p:pRg st="11" end="11"/>
                                             </p:txEl>
                                           </p:spTgt>
                                         </p:tgtEl>
@@ -7573,7 +7509,7 @@
                                         <p:tgtEl>
                                           <p:spTgt spid="6">
                                             <p:txEl>
-                                              <p:pRg st="9" end="9"/>
+                                              <p:pRg st="11" end="11"/>
                                             </p:txEl>
                                           </p:spTgt>
                                         </p:tgtEl>
@@ -7590,7 +7526,7 @@
                                         <p:tgtEl>
                                           <p:spTgt spid="6">
                                             <p:txEl>
-                                              <p:pRg st="9" end="9"/>
+                                              <p:pRg st="11" end="11"/>
                                             </p:txEl>
                                           </p:spTgt>
                                         </p:tgtEl>
@@ -7616,7 +7552,7 @@
                                         <p:tgtEl>
                                           <p:spTgt spid="6">
                                             <p:txEl>
-                                              <p:pRg st="11" end="11"/>
+                                              <p:pRg st="13" end="13"/>
                                             </p:txEl>
                                           </p:spTgt>
                                         </p:tgtEl>
@@ -7638,7 +7574,7 @@
                                         <p:tgtEl>
                                           <p:spTgt spid="6">
                                             <p:txEl>
-                                              <p:pRg st="11" end="11"/>
+                                              <p:pRg st="13" end="13"/>
                                             </p:txEl>
                                           </p:spTgt>
                                         </p:tgtEl>
@@ -7654,7 +7590,7 @@
                                         <p:tgtEl>
                                           <p:spTgt spid="6">
                                             <p:txEl>
-                                              <p:pRg st="11" end="11"/>
+                                              <p:pRg st="13" end="13"/>
                                             </p:txEl>
                                           </p:spTgt>
                                         </p:tgtEl>
@@ -7685,7 +7621,7 @@
                                         <p:tgtEl>
                                           <p:spTgt spid="6">
                                             <p:txEl>
-                                              <p:pRg st="11" end="11"/>
+                                              <p:pRg st="13" end="13"/>
                                             </p:txEl>
                                           </p:spTgt>
                                         </p:tgtEl>
@@ -7716,7 +7652,7 @@
                                         <p:tgtEl>
                                           <p:spTgt spid="6">
                                             <p:txEl>
-                                              <p:pRg st="11" end="11"/>
+                                              <p:pRg st="13" end="13"/>
                                             </p:txEl>
                                           </p:spTgt>
                                         </p:tgtEl>
@@ -7747,7 +7683,7 @@
                                         <p:tgtEl>
                                           <p:spTgt spid="6">
                                             <p:txEl>
-                                              <p:pRg st="11" end="11"/>
+                                              <p:pRg st="13" end="13"/>
                                             </p:txEl>
                                           </p:spTgt>
                                         </p:tgtEl>
@@ -7778,7 +7714,7 @@
                                         <p:tgtEl>
                                           <p:spTgt spid="6">
                                             <p:txEl>
-                                              <p:pRg st="11" end="11"/>
+                                              <p:pRg st="13" end="13"/>
                                             </p:txEl>
                                           </p:spTgt>
                                         </p:tgtEl>
@@ -7809,7 +7745,7 @@
                                         <p:tgtEl>
                                           <p:spTgt spid="6">
                                             <p:txEl>
-                                              <p:pRg st="11" end="11"/>
+                                              <p:pRg st="13" end="13"/>
                                             </p:txEl>
                                           </p:spTgt>
                                         </p:tgtEl>
@@ -7826,7 +7762,7 @@
                                         <p:tgtEl>
                                           <p:spTgt spid="6">
                                             <p:txEl>
-                                              <p:pRg st="11" end="11"/>
+                                              <p:pRg st="13" end="13"/>
                                             </p:txEl>
                                           </p:spTgt>
                                         </p:tgtEl>
@@ -7843,7 +7779,7 @@
                                         <p:tgtEl>
                                           <p:spTgt spid="6">
                                             <p:txEl>
-                                              <p:pRg st="11" end="11"/>
+                                              <p:pRg st="13" end="13"/>
                                             </p:txEl>
                                           </p:spTgt>
                                         </p:tgtEl>
@@ -7860,7 +7796,7 @@
                                         <p:tgtEl>
                                           <p:spTgt spid="6">
                                             <p:txEl>
-                                              <p:pRg st="11" end="11"/>
+                                              <p:pRg st="13" end="13"/>
                                             </p:txEl>
                                           </p:spTgt>
                                         </p:tgtEl>
@@ -7877,7 +7813,7 @@
                                         <p:tgtEl>
                                           <p:spTgt spid="6">
                                             <p:txEl>
-                                              <p:pRg st="11" end="11"/>
+                                              <p:pRg st="13" end="13"/>
                                             </p:txEl>
                                           </p:spTgt>
                                         </p:tgtEl>
@@ -7894,7 +7830,7 @@
                                         <p:tgtEl>
                                           <p:spTgt spid="6">
                                             <p:txEl>
-                                              <p:pRg st="11" end="11"/>
+                                              <p:pRg st="13" end="13"/>
                                             </p:txEl>
                                           </p:spTgt>
                                         </p:tgtEl>
@@ -7911,7 +7847,7 @@
                                         <p:tgtEl>
                                           <p:spTgt spid="6">
                                             <p:txEl>
-                                              <p:pRg st="11" end="11"/>
+                                              <p:pRg st="13" end="13"/>
                                             </p:txEl>
                                           </p:spTgt>
                                         </p:tgtEl>
@@ -7928,7 +7864,7 @@
                                         <p:tgtEl>
                                           <p:spTgt spid="6">
                                             <p:txEl>
-                                              <p:pRg st="11" end="11"/>
+                                              <p:pRg st="13" end="13"/>
                                             </p:txEl>
                                           </p:spTgt>
                                         </p:tgtEl>
@@ -7954,7 +7890,7 @@
                                         <p:tgtEl>
                                           <p:spTgt spid="6">
                                             <p:txEl>
-                                              <p:pRg st="12" end="12"/>
+                                              <p:pRg st="14" end="14"/>
                                             </p:txEl>
                                           </p:spTgt>
                                         </p:tgtEl>
@@ -7976,7 +7912,7 @@
                                         <p:tgtEl>
                                           <p:spTgt spid="6">
                                             <p:txEl>
-                                              <p:pRg st="12" end="12"/>
+                                              <p:pRg st="14" end="14"/>
                                             </p:txEl>
                                           </p:spTgt>
                                         </p:tgtEl>
@@ -7992,7 +7928,7 @@
                                         <p:tgtEl>
                                           <p:spTgt spid="6">
                                             <p:txEl>
-                                              <p:pRg st="12" end="12"/>
+                                              <p:pRg st="14" end="14"/>
                                             </p:txEl>
                                           </p:spTgt>
                                         </p:tgtEl>
@@ -8023,7 +7959,7 @@
                                         <p:tgtEl>
                                           <p:spTgt spid="6">
                                             <p:txEl>
-                                              <p:pRg st="12" end="12"/>
+                                              <p:pRg st="14" end="14"/>
                                             </p:txEl>
                                           </p:spTgt>
                                         </p:tgtEl>
@@ -8054,7 +7990,7 @@
                                         <p:tgtEl>
                                           <p:spTgt spid="6">
                                             <p:txEl>
-                                              <p:pRg st="12" end="12"/>
+                                              <p:pRg st="14" end="14"/>
                                             </p:txEl>
                                           </p:spTgt>
                                         </p:tgtEl>
@@ -8085,7 +8021,7 @@
                                         <p:tgtEl>
                                           <p:spTgt spid="6">
                                             <p:txEl>
-                                              <p:pRg st="12" end="12"/>
+                                              <p:pRg st="14" end="14"/>
                                             </p:txEl>
                                           </p:spTgt>
                                         </p:tgtEl>
@@ -8116,7 +8052,7 @@
                                         <p:tgtEl>
                                           <p:spTgt spid="6">
                                             <p:txEl>
-                                              <p:pRg st="12" end="12"/>
+                                              <p:pRg st="14" end="14"/>
                                             </p:txEl>
                                           </p:spTgt>
                                         </p:tgtEl>
@@ -8147,7 +8083,7 @@
                                         <p:tgtEl>
                                           <p:spTgt spid="6">
                                             <p:txEl>
-                                              <p:pRg st="12" end="12"/>
+                                              <p:pRg st="14" end="14"/>
                                             </p:txEl>
                                           </p:spTgt>
                                         </p:tgtEl>
@@ -8164,7 +8100,7 @@
                                         <p:tgtEl>
                                           <p:spTgt spid="6">
                                             <p:txEl>
-                                              <p:pRg st="12" end="12"/>
+                                              <p:pRg st="14" end="14"/>
                                             </p:txEl>
                                           </p:spTgt>
                                         </p:tgtEl>
@@ -8181,7 +8117,7 @@
                                         <p:tgtEl>
                                           <p:spTgt spid="6">
                                             <p:txEl>
-                                              <p:pRg st="12" end="12"/>
+                                              <p:pRg st="14" end="14"/>
                                             </p:txEl>
                                           </p:spTgt>
                                         </p:tgtEl>
@@ -8198,7 +8134,7 @@
                                         <p:tgtEl>
                                           <p:spTgt spid="6">
                                             <p:txEl>
-                                              <p:pRg st="12" end="12"/>
+                                              <p:pRg st="14" end="14"/>
                                             </p:txEl>
                                           </p:spTgt>
                                         </p:tgtEl>
@@ -8215,7 +8151,7 @@
                                         <p:tgtEl>
                                           <p:spTgt spid="6">
                                             <p:txEl>
-                                              <p:pRg st="12" end="12"/>
+                                              <p:pRg st="14" end="14"/>
                                             </p:txEl>
                                           </p:spTgt>
                                         </p:tgtEl>
@@ -8232,7 +8168,7 @@
                                         <p:tgtEl>
                                           <p:spTgt spid="6">
                                             <p:txEl>
-                                              <p:pRg st="12" end="12"/>
+                                              <p:pRg st="14" end="14"/>
                                             </p:txEl>
                                           </p:spTgt>
                                         </p:tgtEl>
@@ -8249,7 +8185,7 @@
                                         <p:tgtEl>
                                           <p:spTgt spid="6">
                                             <p:txEl>
-                                              <p:pRg st="12" end="12"/>
+                                              <p:pRg st="14" end="14"/>
                                             </p:txEl>
                                           </p:spTgt>
                                         </p:tgtEl>
@@ -8266,7 +8202,7 @@
                                         <p:tgtEl>
                                           <p:spTgt spid="6">
                                             <p:txEl>
-                                              <p:pRg st="12" end="12"/>
+                                              <p:pRg st="14" end="14"/>
                                             </p:txEl>
                                           </p:spTgt>
                                         </p:tgtEl>
@@ -8292,7 +8228,7 @@
                                         <p:tgtEl>
                                           <p:spTgt spid="6">
                                             <p:txEl>
-                                              <p:pRg st="13" end="13"/>
+                                              <p:pRg st="15" end="15"/>
                                             </p:txEl>
                                           </p:spTgt>
                                         </p:tgtEl>
@@ -8314,7 +8250,7 @@
                                         <p:tgtEl>
                                           <p:spTgt spid="6">
                                             <p:txEl>
-                                              <p:pRg st="13" end="13"/>
+                                              <p:pRg st="15" end="15"/>
                                             </p:txEl>
                                           </p:spTgt>
                                         </p:tgtEl>
@@ -8330,7 +8266,7 @@
                                         <p:tgtEl>
                                           <p:spTgt spid="6">
                                             <p:txEl>
-                                              <p:pRg st="13" end="13"/>
+                                              <p:pRg st="15" end="15"/>
                                             </p:txEl>
                                           </p:spTgt>
                                         </p:tgtEl>
@@ -8361,7 +8297,7 @@
                                         <p:tgtEl>
                                           <p:spTgt spid="6">
                                             <p:txEl>
-                                              <p:pRg st="13" end="13"/>
+                                              <p:pRg st="15" end="15"/>
                                             </p:txEl>
                                           </p:spTgt>
                                         </p:tgtEl>
@@ -8392,7 +8328,7 @@
                                         <p:tgtEl>
                                           <p:spTgt spid="6">
                                             <p:txEl>
-                                              <p:pRg st="13" end="13"/>
+                                              <p:pRg st="15" end="15"/>
                                             </p:txEl>
                                           </p:spTgt>
                                         </p:tgtEl>
@@ -8423,7 +8359,7 @@
                                         <p:tgtEl>
                                           <p:spTgt spid="6">
                                             <p:txEl>
-                                              <p:pRg st="13" end="13"/>
+                                              <p:pRg st="15" end="15"/>
                                             </p:txEl>
                                           </p:spTgt>
                                         </p:tgtEl>
@@ -8454,7 +8390,7 @@
                                         <p:tgtEl>
                                           <p:spTgt spid="6">
                                             <p:txEl>
-                                              <p:pRg st="13" end="13"/>
+                                              <p:pRg st="15" end="15"/>
                                             </p:txEl>
                                           </p:spTgt>
                                         </p:tgtEl>
@@ -8485,7 +8421,7 @@
                                         <p:tgtEl>
                                           <p:spTgt spid="6">
                                             <p:txEl>
-                                              <p:pRg st="13" end="13"/>
+                                              <p:pRg st="15" end="15"/>
                                             </p:txEl>
                                           </p:spTgt>
                                         </p:tgtEl>
@@ -8502,7 +8438,7 @@
                                         <p:tgtEl>
                                           <p:spTgt spid="6">
                                             <p:txEl>
-                                              <p:pRg st="13" end="13"/>
+                                              <p:pRg st="15" end="15"/>
                                             </p:txEl>
                                           </p:spTgt>
                                         </p:tgtEl>
@@ -8519,7 +8455,7 @@
                                         <p:tgtEl>
                                           <p:spTgt spid="6">
                                             <p:txEl>
-                                              <p:pRg st="13" end="13"/>
+                                              <p:pRg st="15" end="15"/>
                                             </p:txEl>
                                           </p:spTgt>
                                         </p:tgtEl>
@@ -8536,7 +8472,7 @@
                                         <p:tgtEl>
                                           <p:spTgt spid="6">
                                             <p:txEl>
-                                              <p:pRg st="13" end="13"/>
+                                              <p:pRg st="15" end="15"/>
                                             </p:txEl>
                                           </p:spTgt>
                                         </p:tgtEl>
@@ -8553,7 +8489,7 @@
                                         <p:tgtEl>
                                           <p:spTgt spid="6">
                                             <p:txEl>
-                                              <p:pRg st="13" end="13"/>
+                                              <p:pRg st="15" end="15"/>
                                             </p:txEl>
                                           </p:spTgt>
                                         </p:tgtEl>
@@ -8570,7 +8506,7 @@
                                         <p:tgtEl>
                                           <p:spTgt spid="6">
                                             <p:txEl>
-                                              <p:pRg st="13" end="13"/>
+                                              <p:pRg st="15" end="15"/>
                                             </p:txEl>
                                           </p:spTgt>
                                         </p:tgtEl>
@@ -8587,7 +8523,7 @@
                                         <p:tgtEl>
                                           <p:spTgt spid="6">
                                             <p:txEl>
-                                              <p:pRg st="13" end="13"/>
+                                              <p:pRg st="15" end="15"/>
                                             </p:txEl>
                                           </p:spTgt>
                                         </p:tgtEl>
@@ -8604,7 +8540,7 @@
                                         <p:tgtEl>
                                           <p:spTgt spid="6">
                                             <p:txEl>
-                                              <p:pRg st="13" end="13"/>
+                                              <p:pRg st="15" end="15"/>
                                             </p:txEl>
                                           </p:spTgt>
                                         </p:tgtEl>
@@ -8630,7 +8566,7 @@
                                         <p:tgtEl>
                                           <p:spTgt spid="6">
                                             <p:txEl>
-                                              <p:pRg st="14" end="14"/>
+                                              <p:pRg st="16" end="16"/>
                                             </p:txEl>
                                           </p:spTgt>
                                         </p:tgtEl>
@@ -8652,7 +8588,7 @@
                                         <p:tgtEl>
                                           <p:spTgt spid="6">
                                             <p:txEl>
-                                              <p:pRg st="14" end="14"/>
+                                              <p:pRg st="16" end="16"/>
                                             </p:txEl>
                                           </p:spTgt>
                                         </p:tgtEl>
@@ -8668,7 +8604,7 @@
                                         <p:tgtEl>
                                           <p:spTgt spid="6">
                                             <p:txEl>
-                                              <p:pRg st="14" end="14"/>
+                                              <p:pRg st="16" end="16"/>
                                             </p:txEl>
                                           </p:spTgt>
                                         </p:tgtEl>
@@ -8699,7 +8635,7 @@
                                         <p:tgtEl>
                                           <p:spTgt spid="6">
                                             <p:txEl>
-                                              <p:pRg st="14" end="14"/>
+                                              <p:pRg st="16" end="16"/>
                                             </p:txEl>
                                           </p:spTgt>
                                         </p:tgtEl>
@@ -8730,7 +8666,7 @@
                                         <p:tgtEl>
                                           <p:spTgt spid="6">
                                             <p:txEl>
-                                              <p:pRg st="14" end="14"/>
+                                              <p:pRg st="16" end="16"/>
                                             </p:txEl>
                                           </p:spTgt>
                                         </p:tgtEl>
@@ -8761,7 +8697,7 @@
                                         <p:tgtEl>
                                           <p:spTgt spid="6">
                                             <p:txEl>
-                                              <p:pRg st="14" end="14"/>
+                                              <p:pRg st="16" end="16"/>
                                             </p:txEl>
                                           </p:spTgt>
                                         </p:tgtEl>
@@ -8792,7 +8728,7 @@
                                         <p:tgtEl>
                                           <p:spTgt spid="6">
                                             <p:txEl>
-                                              <p:pRg st="14" end="14"/>
+                                              <p:pRg st="16" end="16"/>
                                             </p:txEl>
                                           </p:spTgt>
                                         </p:tgtEl>
@@ -8823,7 +8759,7 @@
                                         <p:tgtEl>
                                           <p:spTgt spid="6">
                                             <p:txEl>
-                                              <p:pRg st="14" end="14"/>
+                                              <p:pRg st="16" end="16"/>
                                             </p:txEl>
                                           </p:spTgt>
                                         </p:tgtEl>
@@ -8840,7 +8776,7 @@
                                         <p:tgtEl>
                                           <p:spTgt spid="6">
                                             <p:txEl>
-                                              <p:pRg st="14" end="14"/>
+                                              <p:pRg st="16" end="16"/>
                                             </p:txEl>
                                           </p:spTgt>
                                         </p:tgtEl>
@@ -8857,7 +8793,7 @@
                                         <p:tgtEl>
                                           <p:spTgt spid="6">
                                             <p:txEl>
-                                              <p:pRg st="14" end="14"/>
+                                              <p:pRg st="16" end="16"/>
                                             </p:txEl>
                                           </p:spTgt>
                                         </p:tgtEl>
@@ -8874,7 +8810,7 @@
                                         <p:tgtEl>
                                           <p:spTgt spid="6">
                                             <p:txEl>
-                                              <p:pRg st="14" end="14"/>
+                                              <p:pRg st="16" end="16"/>
                                             </p:txEl>
                                           </p:spTgt>
                                         </p:tgtEl>
@@ -8891,7 +8827,7 @@
                                         <p:tgtEl>
                                           <p:spTgt spid="6">
                                             <p:txEl>
-                                              <p:pRg st="14" end="14"/>
+                                              <p:pRg st="16" end="16"/>
                                             </p:txEl>
                                           </p:spTgt>
                                         </p:tgtEl>
@@ -8908,7 +8844,7 @@
                                         <p:tgtEl>
                                           <p:spTgt spid="6">
                                             <p:txEl>
-                                              <p:pRg st="14" end="14"/>
+                                              <p:pRg st="16" end="16"/>
                                             </p:txEl>
                                           </p:spTgt>
                                         </p:tgtEl>
@@ -8925,7 +8861,7 @@
                                         <p:tgtEl>
                                           <p:spTgt spid="6">
                                             <p:txEl>
-                                              <p:pRg st="14" end="14"/>
+                                              <p:pRg st="16" end="16"/>
                                             </p:txEl>
                                           </p:spTgt>
                                         </p:tgtEl>
@@ -8942,7 +8878,7 @@
                                         <p:tgtEl>
                                           <p:spTgt spid="6">
                                             <p:txEl>
-                                              <p:pRg st="14" end="14"/>
+                                              <p:pRg st="16" end="16"/>
                                             </p:txEl>
                                           </p:spTgt>
                                         </p:tgtEl>
@@ -8968,7 +8904,7 @@
                                         <p:tgtEl>
                                           <p:spTgt spid="6">
                                             <p:txEl>
-                                              <p:pRg st="15" end="15"/>
+                                              <p:pRg st="17" end="17"/>
                                             </p:txEl>
                                           </p:spTgt>
                                         </p:tgtEl>
@@ -8990,7 +8926,7 @@
                                         <p:tgtEl>
                                           <p:spTgt spid="6">
                                             <p:txEl>
-                                              <p:pRg st="15" end="15"/>
+                                              <p:pRg st="17" end="17"/>
                                             </p:txEl>
                                           </p:spTgt>
                                         </p:tgtEl>
@@ -9006,7 +8942,7 @@
                                         <p:tgtEl>
                                           <p:spTgt spid="6">
                                             <p:txEl>
-                                              <p:pRg st="15" end="15"/>
+                                              <p:pRg st="17" end="17"/>
                                             </p:txEl>
                                           </p:spTgt>
                                         </p:tgtEl>
@@ -9037,7 +8973,7 @@
                                         <p:tgtEl>
                                           <p:spTgt spid="6">
                                             <p:txEl>
-                                              <p:pRg st="15" end="15"/>
+                                              <p:pRg st="17" end="17"/>
                                             </p:txEl>
                                           </p:spTgt>
                                         </p:tgtEl>
@@ -9068,7 +9004,7 @@
                                         <p:tgtEl>
                                           <p:spTgt spid="6">
                                             <p:txEl>
-                                              <p:pRg st="15" end="15"/>
+                                              <p:pRg st="17" end="17"/>
                                             </p:txEl>
                                           </p:spTgt>
                                         </p:tgtEl>
@@ -9099,7 +9035,7 @@
                                         <p:tgtEl>
                                           <p:spTgt spid="6">
                                             <p:txEl>
-                                              <p:pRg st="15" end="15"/>
+                                              <p:pRg st="17" end="17"/>
                                             </p:txEl>
                                           </p:spTgt>
                                         </p:tgtEl>
@@ -9130,7 +9066,7 @@
                                         <p:tgtEl>
                                           <p:spTgt spid="6">
                                             <p:txEl>
-                                              <p:pRg st="15" end="15"/>
+                                              <p:pRg st="17" end="17"/>
                                             </p:txEl>
                                           </p:spTgt>
                                         </p:tgtEl>
@@ -9161,7 +9097,7 @@
                                         <p:tgtEl>
                                           <p:spTgt spid="6">
                                             <p:txEl>
-                                              <p:pRg st="15" end="15"/>
+                                              <p:pRg st="17" end="17"/>
                                             </p:txEl>
                                           </p:spTgt>
                                         </p:tgtEl>
@@ -9178,7 +9114,7 @@
                                         <p:tgtEl>
                                           <p:spTgt spid="6">
                                             <p:txEl>
-                                              <p:pRg st="15" end="15"/>
+                                              <p:pRg st="17" end="17"/>
                                             </p:txEl>
                                           </p:spTgt>
                                         </p:tgtEl>
@@ -9195,7 +9131,7 @@
                                         <p:tgtEl>
                                           <p:spTgt spid="6">
                                             <p:txEl>
-                                              <p:pRg st="15" end="15"/>
+                                              <p:pRg st="17" end="17"/>
                                             </p:txEl>
                                           </p:spTgt>
                                         </p:tgtEl>
@@ -9212,7 +9148,7 @@
                                         <p:tgtEl>
                                           <p:spTgt spid="6">
                                             <p:txEl>
-                                              <p:pRg st="15" end="15"/>
+                                              <p:pRg st="17" end="17"/>
                                             </p:txEl>
                                           </p:spTgt>
                                         </p:tgtEl>
@@ -9229,7 +9165,7 @@
                                         <p:tgtEl>
                                           <p:spTgt spid="6">
                                             <p:txEl>
-                                              <p:pRg st="15" end="15"/>
+                                              <p:pRg st="17" end="17"/>
                                             </p:txEl>
                                           </p:spTgt>
                                         </p:tgtEl>
@@ -9246,7 +9182,7 @@
                                         <p:tgtEl>
                                           <p:spTgt spid="6">
                                             <p:txEl>
-                                              <p:pRg st="15" end="15"/>
+                                              <p:pRg st="17" end="17"/>
                                             </p:txEl>
                                           </p:spTgt>
                                         </p:tgtEl>
@@ -9263,7 +9199,7 @@
                                         <p:tgtEl>
                                           <p:spTgt spid="6">
                                             <p:txEl>
-                                              <p:pRg st="15" end="15"/>
+                                              <p:pRg st="17" end="17"/>
                                             </p:txEl>
                                           </p:spTgt>
                                         </p:tgtEl>
@@ -9280,7 +9216,7 @@
                                         <p:tgtEl>
                                           <p:spTgt spid="6">
                                             <p:txEl>
-                                              <p:pRg st="15" end="15"/>
+                                              <p:pRg st="17" end="17"/>
                                             </p:txEl>
                                           </p:spTgt>
                                         </p:tgtEl>
@@ -9306,7 +9242,7 @@
                                         <p:tgtEl>
                                           <p:spTgt spid="6">
                                             <p:txEl>
-                                              <p:pRg st="16" end="16"/>
+                                              <p:pRg st="18" end="18"/>
                                             </p:txEl>
                                           </p:spTgt>
                                         </p:tgtEl>
@@ -9328,7 +9264,7 @@
                                         <p:tgtEl>
                                           <p:spTgt spid="6">
                                             <p:txEl>
-                                              <p:pRg st="16" end="16"/>
+                                              <p:pRg st="18" end="18"/>
                                             </p:txEl>
                                           </p:spTgt>
                                         </p:tgtEl>
@@ -9344,7 +9280,7 @@
                                         <p:tgtEl>
                                           <p:spTgt spid="6">
                                             <p:txEl>
-                                              <p:pRg st="16" end="16"/>
+                                              <p:pRg st="18" end="18"/>
                                             </p:txEl>
                                           </p:spTgt>
                                         </p:tgtEl>
@@ -9375,7 +9311,7 @@
                                         <p:tgtEl>
                                           <p:spTgt spid="6">
                                             <p:txEl>
-                                              <p:pRg st="16" end="16"/>
+                                              <p:pRg st="18" end="18"/>
                                             </p:txEl>
                                           </p:spTgt>
                                         </p:tgtEl>
@@ -9406,7 +9342,7 @@
                                         <p:tgtEl>
                                           <p:spTgt spid="6">
                                             <p:txEl>
-                                              <p:pRg st="16" end="16"/>
+                                              <p:pRg st="18" end="18"/>
                                             </p:txEl>
                                           </p:spTgt>
                                         </p:tgtEl>
@@ -9437,7 +9373,7 @@
                                         <p:tgtEl>
                                           <p:spTgt spid="6">
                                             <p:txEl>
-                                              <p:pRg st="16" end="16"/>
+                                              <p:pRg st="18" end="18"/>
                                             </p:txEl>
                                           </p:spTgt>
                                         </p:tgtEl>
@@ -9468,7 +9404,7 @@
                                         <p:tgtEl>
                                           <p:spTgt spid="6">
                                             <p:txEl>
-                                              <p:pRg st="16" end="16"/>
+                                              <p:pRg st="18" end="18"/>
                                             </p:txEl>
                                           </p:spTgt>
                                         </p:tgtEl>
@@ -9499,7 +9435,7 @@
                                         <p:tgtEl>
                                           <p:spTgt spid="6">
                                             <p:txEl>
-                                              <p:pRg st="16" end="16"/>
+                                              <p:pRg st="18" end="18"/>
                                             </p:txEl>
                                           </p:spTgt>
                                         </p:tgtEl>
@@ -9516,7 +9452,7 @@
                                         <p:tgtEl>
                                           <p:spTgt spid="6">
                                             <p:txEl>
-                                              <p:pRg st="16" end="16"/>
+                                              <p:pRg st="18" end="18"/>
                                             </p:txEl>
                                           </p:spTgt>
                                         </p:tgtEl>
@@ -9533,7 +9469,7 @@
                                         <p:tgtEl>
                                           <p:spTgt spid="6">
                                             <p:txEl>
-                                              <p:pRg st="16" end="16"/>
+                                              <p:pRg st="18" end="18"/>
                                             </p:txEl>
                                           </p:spTgt>
                                         </p:tgtEl>
@@ -9550,7 +9486,7 @@
                                         <p:tgtEl>
                                           <p:spTgt spid="6">
                                             <p:txEl>
-                                              <p:pRg st="16" end="16"/>
+                                              <p:pRg st="18" end="18"/>
                                             </p:txEl>
                                           </p:spTgt>
                                         </p:tgtEl>
@@ -9567,7 +9503,7 @@
                                         <p:tgtEl>
                                           <p:spTgt spid="6">
                                             <p:txEl>
-                                              <p:pRg st="16" end="16"/>
+                                              <p:pRg st="18" end="18"/>
                                             </p:txEl>
                                           </p:spTgt>
                                         </p:tgtEl>
@@ -9584,7 +9520,7 @@
                                         <p:tgtEl>
                                           <p:spTgt spid="6">
                                             <p:txEl>
-                                              <p:pRg st="16" end="16"/>
+                                              <p:pRg st="18" end="18"/>
                                             </p:txEl>
                                           </p:spTgt>
                                         </p:tgtEl>
@@ -9601,7 +9537,7 @@
                                         <p:tgtEl>
                                           <p:spTgt spid="6">
                                             <p:txEl>
-                                              <p:pRg st="16" end="16"/>
+                                              <p:pRg st="18" end="18"/>
                                             </p:txEl>
                                           </p:spTgt>
                                         </p:tgtEl>
@@ -9618,7 +9554,7 @@
                                         <p:tgtEl>
                                           <p:spTgt spid="6">
                                             <p:txEl>
-                                              <p:pRg st="16" end="16"/>
+                                              <p:pRg st="18" end="18"/>
                                             </p:txEl>
                                           </p:spTgt>
                                         </p:tgtEl>
@@ -9644,7 +9580,7 @@
                                         <p:tgtEl>
                                           <p:spTgt spid="6">
                                             <p:txEl>
-                                              <p:pRg st="17" end="17"/>
+                                              <p:pRg st="19" end="19"/>
                                             </p:txEl>
                                           </p:spTgt>
                                         </p:tgtEl>
@@ -9666,7 +9602,7 @@
                                         <p:tgtEl>
                                           <p:spTgt spid="6">
                                             <p:txEl>
-                                              <p:pRg st="17" end="17"/>
+                                              <p:pRg st="19" end="19"/>
                                             </p:txEl>
                                           </p:spTgt>
                                         </p:tgtEl>
@@ -9682,7 +9618,7 @@
                                         <p:tgtEl>
                                           <p:spTgt spid="6">
                                             <p:txEl>
-                                              <p:pRg st="17" end="17"/>
+                                              <p:pRg st="19" end="19"/>
                                             </p:txEl>
                                           </p:spTgt>
                                         </p:tgtEl>
@@ -9713,7 +9649,7 @@
                                         <p:tgtEl>
                                           <p:spTgt spid="6">
                                             <p:txEl>
-                                              <p:pRg st="17" end="17"/>
+                                              <p:pRg st="19" end="19"/>
                                             </p:txEl>
                                           </p:spTgt>
                                         </p:tgtEl>
@@ -9744,7 +9680,7 @@
                                         <p:tgtEl>
                                           <p:spTgt spid="6">
                                             <p:txEl>
-                                              <p:pRg st="17" end="17"/>
+                                              <p:pRg st="19" end="19"/>
                                             </p:txEl>
                                           </p:spTgt>
                                         </p:tgtEl>
@@ -9775,7 +9711,7 @@
                                         <p:tgtEl>
                                           <p:spTgt spid="6">
                                             <p:txEl>
-                                              <p:pRg st="17" end="17"/>
+                                              <p:pRg st="19" end="19"/>
                                             </p:txEl>
                                           </p:spTgt>
                                         </p:tgtEl>
@@ -9806,7 +9742,7 @@
                                         <p:tgtEl>
                                           <p:spTgt spid="6">
                                             <p:txEl>
-                                              <p:pRg st="17" end="17"/>
+                                              <p:pRg st="19" end="19"/>
                                             </p:txEl>
                                           </p:spTgt>
                                         </p:tgtEl>
@@ -9837,7 +9773,7 @@
                                         <p:tgtEl>
                                           <p:spTgt spid="6">
                                             <p:txEl>
-                                              <p:pRg st="17" end="17"/>
+                                              <p:pRg st="19" end="19"/>
                                             </p:txEl>
                                           </p:spTgt>
                                         </p:tgtEl>
@@ -9854,7 +9790,7 @@
                                         <p:tgtEl>
                                           <p:spTgt spid="6">
                                             <p:txEl>
-                                              <p:pRg st="17" end="17"/>
+                                              <p:pRg st="19" end="19"/>
                                             </p:txEl>
                                           </p:spTgt>
                                         </p:tgtEl>
@@ -9871,7 +9807,7 @@
                                         <p:tgtEl>
                                           <p:spTgt spid="6">
                                             <p:txEl>
-                                              <p:pRg st="17" end="17"/>
+                                              <p:pRg st="19" end="19"/>
                                             </p:txEl>
                                           </p:spTgt>
                                         </p:tgtEl>
@@ -9888,7 +9824,7 @@
                                         <p:tgtEl>
                                           <p:spTgt spid="6">
                                             <p:txEl>
-                                              <p:pRg st="17" end="17"/>
+                                              <p:pRg st="19" end="19"/>
                                             </p:txEl>
                                           </p:spTgt>
                                         </p:tgtEl>
@@ -9905,7 +9841,7 @@
                                         <p:tgtEl>
                                           <p:spTgt spid="6">
                                             <p:txEl>
-                                              <p:pRg st="17" end="17"/>
+                                              <p:pRg st="19" end="19"/>
                                             </p:txEl>
                                           </p:spTgt>
                                         </p:tgtEl>
@@ -9922,7 +9858,7 @@
                                         <p:tgtEl>
                                           <p:spTgt spid="6">
                                             <p:txEl>
-                                              <p:pRg st="17" end="17"/>
+                                              <p:pRg st="19" end="19"/>
                                             </p:txEl>
                                           </p:spTgt>
                                         </p:tgtEl>
@@ -9939,7 +9875,7 @@
                                         <p:tgtEl>
                                           <p:spTgt spid="6">
                                             <p:txEl>
-                                              <p:pRg st="17" end="17"/>
+                                              <p:pRg st="19" end="19"/>
                                             </p:txEl>
                                           </p:spTgt>
                                         </p:tgtEl>
@@ -9956,7 +9892,7 @@
                                         <p:tgtEl>
                                           <p:spTgt spid="6">
                                             <p:txEl>
-                                              <p:pRg st="17" end="17"/>
+                                              <p:pRg st="19" end="19"/>
                                             </p:txEl>
                                           </p:spTgt>
                                         </p:tgtEl>
@@ -10447,7 +10383,7 @@
         <p:spPr>
           <a:xfrm>
             <a:off x="15230" y="513661"/>
-            <a:ext cx="4440051" cy="5119310"/>
+            <a:ext cx="4440051" cy="4565312"/>
           </a:xfrm>
           <a:prstGeom prst="rect">
             <a:avLst/>
@@ -10463,6 +10399,9 @@
           </a:bodyPr>
           <a:lstStyle/>
           <a:p>
+            <a:endParaRPr lang="en-US" sz="900" b="1" dirty="0"/>
+          </a:p>
+          <a:p>
             <a:r>
               <a:rPr lang="en-US" sz="900" b="1" dirty="0"/>
               <a:t>Data Ingestion (Python):</a:t>
@@ -10471,6 +10410,9 @@
               <a:rPr lang="en-US" sz="900" dirty="0"/>
               <a:t> The system automatically fetches live market feeds and the latest financial news based on the user-entered stock ticker (e.g., TCS.NS).</a:t>
             </a:r>
+          </a:p>
+          <a:p>
+            <a:endParaRPr lang="en-US" sz="900" dirty="0"/>
           </a:p>
           <a:p>
             <a:r>
@@ -10489,6 +10431,9 @@
               <a:rPr lang="en-US" sz="900" dirty="0"/>
               <a:t> (supporting English/Hindi).</a:t>
             </a:r>
+          </a:p>
+          <a:p>
+            <a:endParaRPr lang="en-US" sz="900" dirty="0"/>
           </a:p>
           <a:p>
             <a:r>
@@ -10525,6 +10470,9 @@
             </a:r>
           </a:p>
           <a:p>
+            <a:endParaRPr lang="en-US" sz="900" b="1" dirty="0"/>
+          </a:p>
+          <a:p>
             <a:r>
               <a:rPr lang="en-US" sz="900" b="1" dirty="0"/>
               <a:t>UI Delivery (Streamlit &amp; Plotly):</a:t>
@@ -10543,46 +10491,7 @@
             </a:r>
           </a:p>
           <a:p>
-            <a:r>
-              <a:rPr lang="en-US" sz="900" b="1" dirty="0"/>
-              <a:t>🚀 Key Technical Value</a:t>
-            </a:r>
-          </a:p>
-          <a:p>
-            <a:r>
-              <a:rPr lang="en-US" sz="900" b="1" dirty="0"/>
-              <a:t>Jargon-Free Insights:</a:t>
-            </a:r>
-            <a:r>
-              <a:rPr lang="en-US" sz="900" dirty="0"/>
-              <a:t> Empowers retail investors by translating complex data into plain language.</a:t>
-            </a:r>
-          </a:p>
-          <a:p>
-            <a:r>
-              <a:rPr lang="en-US" sz="900" b="1" dirty="0"/>
-              <a:t>Time Efficiency:</a:t>
-            </a:r>
-            <a:r>
-              <a:rPr lang="en-US" sz="900" dirty="0"/>
-              <a:t> Eliminates the need to scan financial news 24/7 by delivering instant summaries.</a:t>
-            </a:r>
-          </a:p>
-          <a:p>
-            <a:r>
-              <a:rPr lang="en-US" sz="900" b="1" dirty="0"/>
-              <a:t>Rapid Deployment:</a:t>
-            </a:r>
-            <a:r>
-              <a:rPr lang="en-US" sz="900" dirty="0"/>
-              <a:t> Built on a lightweight, highly responsive tech stack optimized for fast prototyping.</a:t>
-            </a:r>
-          </a:p>
-          <a:p>
-            <a:r>
-              <a:rPr lang="en-US" sz="900" b="1" dirty="0"/>
-              <a:t>System Architecture (How It Works)</a:t>
-            </a:r>
+            <a:endParaRPr lang="en-US" sz="900" b="1" dirty="0"/>
           </a:p>
           <a:p>
             <a:r>
@@ -10591,26 +10500,11 @@
             </a:r>
             <a:r>
               <a:rPr lang="en-US" sz="900" dirty="0"/>
-              <a:t> The system automatically fetches live market feeds and the latest financial news based on the user-entered stock ticker (e.g., TCS.NS).</a:t>
+              <a:t> Automatically fetches live market feeds and financial news based on user-entered stock tickers.</a:t>
             </a:r>
           </a:p>
           <a:p>
-            <a:r>
-              <a:rPr lang="en-US" sz="900" b="1" dirty="0"/>
-              <a:t>AI Engine (Google Gemini API):</a:t>
-            </a:r>
-            <a:r>
-              <a:rPr lang="en-US" sz="900" dirty="0"/>
-              <a:t> Processes heavy financial jargon and dense articles to generate simplified, easy-to-understand </a:t>
-            </a:r>
-            <a:r>
-              <a:rPr lang="en-US" sz="900" b="1" dirty="0"/>
-              <a:t>2–3 key bullet points</a:t>
-            </a:r>
-            <a:r>
-              <a:rPr lang="en-US" sz="900" dirty="0"/>
-              <a:t> (supporting English/Hindi).</a:t>
-            </a:r>
+            <a:endParaRPr lang="en-US" sz="900" dirty="0"/>
           </a:p>
           <a:p>
             <a:r>
@@ -10619,7 +10513,7 @@
             </a:r>
             <a:r>
               <a:rPr lang="en-US" sz="900" dirty="0"/>
-              <a:t> Instantly categorizes the news impact as </a:t>
+              <a:t> Instantly categorizes news impact as </a:t>
             </a:r>
             <a:r>
               <a:rPr lang="en-US" sz="900" b="1" dirty="0"/>
@@ -10643,31 +10537,16 @@
             </a:r>
             <a:r>
               <a:rPr lang="en-US" sz="900" dirty="0"/>
-              <a:t> to guide quick decision-making.</a:t>
+              <a:t>.</a:t>
             </a:r>
+          </a:p>
+          <a:p>
+            <a:endParaRPr lang="en-US" sz="900" b="1" dirty="0"/>
           </a:p>
           <a:p>
             <a:r>
               <a:rPr lang="en-US" sz="900" b="1" dirty="0"/>
-              <a:t>UI Delivery (Streamlit &amp; Plotly):</a:t>
-            </a:r>
-            <a:r>
-              <a:rPr lang="en-US" sz="900" dirty="0"/>
-              <a:t> Renders a clean, interactive web dashboard combining real-time stock price </a:t>
-            </a:r>
-            <a:r>
-              <a:rPr lang="en-US" sz="900" b="1" dirty="0"/>
-              <a:t>Line Charts</a:t>
-            </a:r>
-            <a:r>
-              <a:rPr lang="en-US" sz="900" dirty="0"/>
-              <a:t> with precise AI insights side-by-side.</a:t>
-            </a:r>
-          </a:p>
-          <a:p>
-            <a:r>
-              <a:rPr lang="en-US" sz="900" b="1" dirty="0"/>
-              <a:t>🚀 Key Technical Value</a:t>
+              <a:t>Key Technical Value</a:t>
             </a:r>
           </a:p>
           <a:p>
@@ -10677,8 +10556,11 @@
             </a:r>
             <a:r>
               <a:rPr lang="en-US" sz="900" dirty="0"/>
-              <a:t> Empowers retail investors by translating complex data into plain language.</a:t>
+              <a:t> Translates complex financial data into plain, accessible language for retail investors.</a:t>
             </a:r>
+          </a:p>
+          <a:p>
+            <a:endParaRPr lang="en-US" sz="900" dirty="0"/>
           </a:p>
           <a:p>
             <a:r>
@@ -10687,8 +10569,11 @@
             </a:r>
             <a:r>
               <a:rPr lang="en-US" sz="900" dirty="0"/>
-              <a:t> Eliminates the need to scan financial news 24/7 by delivering instant summaries.</a:t>
+              <a:t> Saves time by delivering instant summaries instead of requiring 24/7 news monitoring.</a:t>
             </a:r>
+          </a:p>
+          <a:p>
+            <a:endParaRPr lang="en-US" sz="900" dirty="0"/>
           </a:p>
           <a:p>
             <a:r>
@@ -10722,13 +10607,13 @@
   <p:clrMapOvr>
     <a:masterClrMapping/>
   </p:clrMapOvr>
-  <mc:AlternateContent xmlns:mc="http://schemas.openxmlformats.org/markup-compatibility/2006">
-    <mc:Choice xmlns:p159="http://schemas.microsoft.com/office/powerpoint/2015/09/main" Requires="p159">
+  <mc:AlternateContent xmlns:mc="http://schemas.openxmlformats.org/markup-compatibility/2006" xmlns:p159="http://schemas.microsoft.com/office/powerpoint/2015/09/main">
+    <mc:Choice Requires="p159">
       <p:transition xmlns:p14="http://schemas.microsoft.com/office/powerpoint/2010/main" spd="slow" p14:dur="2000">
         <p159:morph option="byObject"/>
       </p:transition>
     </mc:Choice>
-    <mc:Fallback>
+    <mc:Fallback xmlns="">
       <p:transition spd="slow">
         <p:fade/>
       </p:transition>
@@ -10824,755 +10709,6 @@
                                         </p:tav>
                                       </p:tavLst>
                                     </p:anim>
-                                  </p:childTnLst>
-                                </p:cTn>
-                              </p:par>
-                            </p:childTnLst>
-                          </p:cTn>
-                        </p:par>
-                      </p:childTnLst>
-                    </p:cTn>
-                  </p:par>
-                  <p:par>
-                    <p:cTn id="9" fill="hold">
-                      <p:stCondLst>
-                        <p:cond delay="indefinite"/>
-                      </p:stCondLst>
-                      <p:childTnLst>
-                        <p:par>
-                          <p:cTn id="10" fill="hold">
-                            <p:stCondLst>
-                              <p:cond delay="0"/>
-                            </p:stCondLst>
-                            <p:childTnLst>
-                              <p:par>
-                                <p:cTn id="11" presetID="21" presetClass="entr" presetSubtype="1" fill="hold" nodeType="clickEffect">
-                                  <p:stCondLst>
-                                    <p:cond delay="0"/>
-                                  </p:stCondLst>
-                                  <p:childTnLst>
-                                    <p:set>
-                                      <p:cBhvr>
-                                        <p:cTn id="12" dur="1" fill="hold">
-                                          <p:stCondLst>
-                                            <p:cond delay="0"/>
-                                          </p:stCondLst>
-                                        </p:cTn>
-                                        <p:tgtEl>
-                                          <p:spTgt spid="26">
-                                            <p:txEl>
-                                              <p:pRg st="0" end="0"/>
-                                            </p:txEl>
-                                          </p:spTgt>
-                                        </p:tgtEl>
-                                        <p:attrNameLst>
-                                          <p:attrName>style.visibility</p:attrName>
-                                        </p:attrNameLst>
-                                      </p:cBhvr>
-                                      <p:to>
-                                        <p:strVal val="visible"/>
-                                      </p:to>
-                                    </p:set>
-                                    <p:animEffect transition="in" filter="wheel(1)">
-                                      <p:cBhvr>
-                                        <p:cTn id="13" dur="2000"/>
-                                        <p:tgtEl>
-                                          <p:spTgt spid="26">
-                                            <p:txEl>
-                                              <p:pRg st="0" end="0"/>
-                                            </p:txEl>
-                                          </p:spTgt>
-                                        </p:tgtEl>
-                                      </p:cBhvr>
-                                    </p:animEffect>
-                                  </p:childTnLst>
-                                </p:cTn>
-                              </p:par>
-                              <p:par>
-                                <p:cTn id="14" presetID="21" presetClass="entr" presetSubtype="1" fill="hold" nodeType="withEffect">
-                                  <p:stCondLst>
-                                    <p:cond delay="0"/>
-                                  </p:stCondLst>
-                                  <p:childTnLst>
-                                    <p:set>
-                                      <p:cBhvr>
-                                        <p:cTn id="15" dur="1" fill="hold">
-                                          <p:stCondLst>
-                                            <p:cond delay="0"/>
-                                          </p:stCondLst>
-                                        </p:cTn>
-                                        <p:tgtEl>
-                                          <p:spTgt spid="26">
-                                            <p:txEl>
-                                              <p:pRg st="1" end="1"/>
-                                            </p:txEl>
-                                          </p:spTgt>
-                                        </p:tgtEl>
-                                        <p:attrNameLst>
-                                          <p:attrName>style.visibility</p:attrName>
-                                        </p:attrNameLst>
-                                      </p:cBhvr>
-                                      <p:to>
-                                        <p:strVal val="visible"/>
-                                      </p:to>
-                                    </p:set>
-                                    <p:animEffect transition="in" filter="wheel(1)">
-                                      <p:cBhvr>
-                                        <p:cTn id="16" dur="2000"/>
-                                        <p:tgtEl>
-                                          <p:spTgt spid="26">
-                                            <p:txEl>
-                                              <p:pRg st="1" end="1"/>
-                                            </p:txEl>
-                                          </p:spTgt>
-                                        </p:tgtEl>
-                                      </p:cBhvr>
-                                    </p:animEffect>
-                                  </p:childTnLst>
-                                </p:cTn>
-                              </p:par>
-                              <p:par>
-                                <p:cTn id="17" presetID="21" presetClass="entr" presetSubtype="1" fill="hold" nodeType="withEffect">
-                                  <p:stCondLst>
-                                    <p:cond delay="0"/>
-                                  </p:stCondLst>
-                                  <p:childTnLst>
-                                    <p:set>
-                                      <p:cBhvr>
-                                        <p:cTn id="18" dur="1" fill="hold">
-                                          <p:stCondLst>
-                                            <p:cond delay="0"/>
-                                          </p:stCondLst>
-                                        </p:cTn>
-                                        <p:tgtEl>
-                                          <p:spTgt spid="26">
-                                            <p:txEl>
-                                              <p:pRg st="2" end="2"/>
-                                            </p:txEl>
-                                          </p:spTgt>
-                                        </p:tgtEl>
-                                        <p:attrNameLst>
-                                          <p:attrName>style.visibility</p:attrName>
-                                        </p:attrNameLst>
-                                      </p:cBhvr>
-                                      <p:to>
-                                        <p:strVal val="visible"/>
-                                      </p:to>
-                                    </p:set>
-                                    <p:animEffect transition="in" filter="wheel(1)">
-                                      <p:cBhvr>
-                                        <p:cTn id="19" dur="2000"/>
-                                        <p:tgtEl>
-                                          <p:spTgt spid="26">
-                                            <p:txEl>
-                                              <p:pRg st="2" end="2"/>
-                                            </p:txEl>
-                                          </p:spTgt>
-                                        </p:tgtEl>
-                                      </p:cBhvr>
-                                    </p:animEffect>
-                                  </p:childTnLst>
-                                </p:cTn>
-                              </p:par>
-                              <p:par>
-                                <p:cTn id="20" presetID="21" presetClass="entr" presetSubtype="1" fill="hold" nodeType="withEffect">
-                                  <p:stCondLst>
-                                    <p:cond delay="0"/>
-                                  </p:stCondLst>
-                                  <p:childTnLst>
-                                    <p:set>
-                                      <p:cBhvr>
-                                        <p:cTn id="21" dur="1" fill="hold">
-                                          <p:stCondLst>
-                                            <p:cond delay="0"/>
-                                          </p:stCondLst>
-                                        </p:cTn>
-                                        <p:tgtEl>
-                                          <p:spTgt spid="26">
-                                            <p:txEl>
-                                              <p:pRg st="3" end="3"/>
-                                            </p:txEl>
-                                          </p:spTgt>
-                                        </p:tgtEl>
-                                        <p:attrNameLst>
-                                          <p:attrName>style.visibility</p:attrName>
-                                        </p:attrNameLst>
-                                      </p:cBhvr>
-                                      <p:to>
-                                        <p:strVal val="visible"/>
-                                      </p:to>
-                                    </p:set>
-                                    <p:animEffect transition="in" filter="wheel(1)">
-                                      <p:cBhvr>
-                                        <p:cTn id="22" dur="2000"/>
-                                        <p:tgtEl>
-                                          <p:spTgt spid="26">
-                                            <p:txEl>
-                                              <p:pRg st="3" end="3"/>
-                                            </p:txEl>
-                                          </p:spTgt>
-                                        </p:tgtEl>
-                                      </p:cBhvr>
-                                    </p:animEffect>
-                                  </p:childTnLst>
-                                </p:cTn>
-                              </p:par>
-                              <p:par>
-                                <p:cTn id="23" presetID="21" presetClass="entr" presetSubtype="1" fill="hold" nodeType="withEffect">
-                                  <p:stCondLst>
-                                    <p:cond delay="0"/>
-                                  </p:stCondLst>
-                                  <p:childTnLst>
-                                    <p:set>
-                                      <p:cBhvr>
-                                        <p:cTn id="24" dur="1" fill="hold">
-                                          <p:stCondLst>
-                                            <p:cond delay="0"/>
-                                          </p:stCondLst>
-                                        </p:cTn>
-                                        <p:tgtEl>
-                                          <p:spTgt spid="26">
-                                            <p:txEl>
-                                              <p:pRg st="4" end="4"/>
-                                            </p:txEl>
-                                          </p:spTgt>
-                                        </p:tgtEl>
-                                        <p:attrNameLst>
-                                          <p:attrName>style.visibility</p:attrName>
-                                        </p:attrNameLst>
-                                      </p:cBhvr>
-                                      <p:to>
-                                        <p:strVal val="visible"/>
-                                      </p:to>
-                                    </p:set>
-                                    <p:animEffect transition="in" filter="wheel(1)">
-                                      <p:cBhvr>
-                                        <p:cTn id="25" dur="2000"/>
-                                        <p:tgtEl>
-                                          <p:spTgt spid="26">
-                                            <p:txEl>
-                                              <p:pRg st="4" end="4"/>
-                                            </p:txEl>
-                                          </p:spTgt>
-                                        </p:tgtEl>
-                                      </p:cBhvr>
-                                    </p:animEffect>
-                                  </p:childTnLst>
-                                </p:cTn>
-                              </p:par>
-                              <p:par>
-                                <p:cTn id="26" presetID="21" presetClass="entr" presetSubtype="1" fill="hold" nodeType="withEffect">
-                                  <p:stCondLst>
-                                    <p:cond delay="0"/>
-                                  </p:stCondLst>
-                                  <p:childTnLst>
-                                    <p:set>
-                                      <p:cBhvr>
-                                        <p:cTn id="27" dur="1" fill="hold">
-                                          <p:stCondLst>
-                                            <p:cond delay="0"/>
-                                          </p:stCondLst>
-                                        </p:cTn>
-                                        <p:tgtEl>
-                                          <p:spTgt spid="26">
-                                            <p:txEl>
-                                              <p:pRg st="5" end="5"/>
-                                            </p:txEl>
-                                          </p:spTgt>
-                                        </p:tgtEl>
-                                        <p:attrNameLst>
-                                          <p:attrName>style.visibility</p:attrName>
-                                        </p:attrNameLst>
-                                      </p:cBhvr>
-                                      <p:to>
-                                        <p:strVal val="visible"/>
-                                      </p:to>
-                                    </p:set>
-                                    <p:animEffect transition="in" filter="wheel(1)">
-                                      <p:cBhvr>
-                                        <p:cTn id="28" dur="2000"/>
-                                        <p:tgtEl>
-                                          <p:spTgt spid="26">
-                                            <p:txEl>
-                                              <p:pRg st="5" end="5"/>
-                                            </p:txEl>
-                                          </p:spTgt>
-                                        </p:tgtEl>
-                                      </p:cBhvr>
-                                    </p:animEffect>
-                                  </p:childTnLst>
-                                </p:cTn>
-                              </p:par>
-                              <p:par>
-                                <p:cTn id="29" presetID="21" presetClass="entr" presetSubtype="1" fill="hold" nodeType="withEffect">
-                                  <p:stCondLst>
-                                    <p:cond delay="0"/>
-                                  </p:stCondLst>
-                                  <p:childTnLst>
-                                    <p:set>
-                                      <p:cBhvr>
-                                        <p:cTn id="30" dur="1" fill="hold">
-                                          <p:stCondLst>
-                                            <p:cond delay="0"/>
-                                          </p:stCondLst>
-                                        </p:cTn>
-                                        <p:tgtEl>
-                                          <p:spTgt spid="26">
-                                            <p:txEl>
-                                              <p:pRg st="6" end="6"/>
-                                            </p:txEl>
-                                          </p:spTgt>
-                                        </p:tgtEl>
-                                        <p:attrNameLst>
-                                          <p:attrName>style.visibility</p:attrName>
-                                        </p:attrNameLst>
-                                      </p:cBhvr>
-                                      <p:to>
-                                        <p:strVal val="visible"/>
-                                      </p:to>
-                                    </p:set>
-                                    <p:animEffect transition="in" filter="wheel(1)">
-                                      <p:cBhvr>
-                                        <p:cTn id="31" dur="2000"/>
-                                        <p:tgtEl>
-                                          <p:spTgt spid="26">
-                                            <p:txEl>
-                                              <p:pRg st="6" end="6"/>
-                                            </p:txEl>
-                                          </p:spTgt>
-                                        </p:tgtEl>
-                                      </p:cBhvr>
-                                    </p:animEffect>
-                                  </p:childTnLst>
-                                </p:cTn>
-                              </p:par>
-                              <p:par>
-                                <p:cTn id="32" presetID="21" presetClass="entr" presetSubtype="1" fill="hold" nodeType="withEffect">
-                                  <p:stCondLst>
-                                    <p:cond delay="0"/>
-                                  </p:stCondLst>
-                                  <p:childTnLst>
-                                    <p:set>
-                                      <p:cBhvr>
-                                        <p:cTn id="33" dur="1" fill="hold">
-                                          <p:stCondLst>
-                                            <p:cond delay="0"/>
-                                          </p:stCondLst>
-                                        </p:cTn>
-                                        <p:tgtEl>
-                                          <p:spTgt spid="26">
-                                            <p:txEl>
-                                              <p:pRg st="7" end="7"/>
-                                            </p:txEl>
-                                          </p:spTgt>
-                                        </p:tgtEl>
-                                        <p:attrNameLst>
-                                          <p:attrName>style.visibility</p:attrName>
-                                        </p:attrNameLst>
-                                      </p:cBhvr>
-                                      <p:to>
-                                        <p:strVal val="visible"/>
-                                      </p:to>
-                                    </p:set>
-                                    <p:animEffect transition="in" filter="wheel(1)">
-                                      <p:cBhvr>
-                                        <p:cTn id="34" dur="2000"/>
-                                        <p:tgtEl>
-                                          <p:spTgt spid="26">
-                                            <p:txEl>
-                                              <p:pRg st="7" end="7"/>
-                                            </p:txEl>
-                                          </p:spTgt>
-                                        </p:tgtEl>
-                                      </p:cBhvr>
-                                    </p:animEffect>
-                                  </p:childTnLst>
-                                </p:cTn>
-                              </p:par>
-                              <p:par>
-                                <p:cTn id="35" presetID="21" presetClass="entr" presetSubtype="1" fill="hold" nodeType="withEffect">
-                                  <p:stCondLst>
-                                    <p:cond delay="0"/>
-                                  </p:stCondLst>
-                                  <p:childTnLst>
-                                    <p:set>
-                                      <p:cBhvr>
-                                        <p:cTn id="36" dur="1" fill="hold">
-                                          <p:stCondLst>
-                                            <p:cond delay="0"/>
-                                          </p:stCondLst>
-                                        </p:cTn>
-                                        <p:tgtEl>
-                                          <p:spTgt spid="26">
-                                            <p:txEl>
-                                              <p:pRg st="8" end="8"/>
-                                            </p:txEl>
-                                          </p:spTgt>
-                                        </p:tgtEl>
-                                        <p:attrNameLst>
-                                          <p:attrName>style.visibility</p:attrName>
-                                        </p:attrNameLst>
-                                      </p:cBhvr>
-                                      <p:to>
-                                        <p:strVal val="visible"/>
-                                      </p:to>
-                                    </p:set>
-                                    <p:animEffect transition="in" filter="wheel(1)">
-                                      <p:cBhvr>
-                                        <p:cTn id="37" dur="2000"/>
-                                        <p:tgtEl>
-                                          <p:spTgt spid="26">
-                                            <p:txEl>
-                                              <p:pRg st="8" end="8"/>
-                                            </p:txEl>
-                                          </p:spTgt>
-                                        </p:tgtEl>
-                                      </p:cBhvr>
-                                    </p:animEffect>
-                                  </p:childTnLst>
-                                </p:cTn>
-                              </p:par>
-                              <p:par>
-                                <p:cTn id="38" presetID="21" presetClass="entr" presetSubtype="1" fill="hold" nodeType="withEffect">
-                                  <p:stCondLst>
-                                    <p:cond delay="0"/>
-                                  </p:stCondLst>
-                                  <p:childTnLst>
-                                    <p:set>
-                                      <p:cBhvr>
-                                        <p:cTn id="39" dur="1" fill="hold">
-                                          <p:stCondLst>
-                                            <p:cond delay="0"/>
-                                          </p:stCondLst>
-                                        </p:cTn>
-                                        <p:tgtEl>
-                                          <p:spTgt spid="26">
-                                            <p:txEl>
-                                              <p:pRg st="9" end="9"/>
-                                            </p:txEl>
-                                          </p:spTgt>
-                                        </p:tgtEl>
-                                        <p:attrNameLst>
-                                          <p:attrName>style.visibility</p:attrName>
-                                        </p:attrNameLst>
-                                      </p:cBhvr>
-                                      <p:to>
-                                        <p:strVal val="visible"/>
-                                      </p:to>
-                                    </p:set>
-                                    <p:animEffect transition="in" filter="wheel(1)">
-                                      <p:cBhvr>
-                                        <p:cTn id="40" dur="2000"/>
-                                        <p:tgtEl>
-                                          <p:spTgt spid="26">
-                                            <p:txEl>
-                                              <p:pRg st="9" end="9"/>
-                                            </p:txEl>
-                                          </p:spTgt>
-                                        </p:tgtEl>
-                                      </p:cBhvr>
-                                    </p:animEffect>
-                                  </p:childTnLst>
-                                </p:cTn>
-                              </p:par>
-                              <p:par>
-                                <p:cTn id="41" presetID="21" presetClass="entr" presetSubtype="1" fill="hold" nodeType="withEffect">
-                                  <p:stCondLst>
-                                    <p:cond delay="0"/>
-                                  </p:stCondLst>
-                                  <p:childTnLst>
-                                    <p:set>
-                                      <p:cBhvr>
-                                        <p:cTn id="42" dur="1" fill="hold">
-                                          <p:stCondLst>
-                                            <p:cond delay="0"/>
-                                          </p:stCondLst>
-                                        </p:cTn>
-                                        <p:tgtEl>
-                                          <p:spTgt spid="26">
-                                            <p:txEl>
-                                              <p:pRg st="10" end="10"/>
-                                            </p:txEl>
-                                          </p:spTgt>
-                                        </p:tgtEl>
-                                        <p:attrNameLst>
-                                          <p:attrName>style.visibility</p:attrName>
-                                        </p:attrNameLst>
-                                      </p:cBhvr>
-                                      <p:to>
-                                        <p:strVal val="visible"/>
-                                      </p:to>
-                                    </p:set>
-                                    <p:animEffect transition="in" filter="wheel(1)">
-                                      <p:cBhvr>
-                                        <p:cTn id="43" dur="2000"/>
-                                        <p:tgtEl>
-                                          <p:spTgt spid="26">
-                                            <p:txEl>
-                                              <p:pRg st="10" end="10"/>
-                                            </p:txEl>
-                                          </p:spTgt>
-                                        </p:tgtEl>
-                                      </p:cBhvr>
-                                    </p:animEffect>
-                                  </p:childTnLst>
-                                </p:cTn>
-                              </p:par>
-                              <p:par>
-                                <p:cTn id="44" presetID="21" presetClass="entr" presetSubtype="1" fill="hold" nodeType="withEffect">
-                                  <p:stCondLst>
-                                    <p:cond delay="0"/>
-                                  </p:stCondLst>
-                                  <p:childTnLst>
-                                    <p:set>
-                                      <p:cBhvr>
-                                        <p:cTn id="45" dur="1" fill="hold">
-                                          <p:stCondLst>
-                                            <p:cond delay="0"/>
-                                          </p:stCondLst>
-                                        </p:cTn>
-                                        <p:tgtEl>
-                                          <p:spTgt spid="26">
-                                            <p:txEl>
-                                              <p:pRg st="11" end="11"/>
-                                            </p:txEl>
-                                          </p:spTgt>
-                                        </p:tgtEl>
-                                        <p:attrNameLst>
-                                          <p:attrName>style.visibility</p:attrName>
-                                        </p:attrNameLst>
-                                      </p:cBhvr>
-                                      <p:to>
-                                        <p:strVal val="visible"/>
-                                      </p:to>
-                                    </p:set>
-                                    <p:animEffect transition="in" filter="wheel(1)">
-                                      <p:cBhvr>
-                                        <p:cTn id="46" dur="2000"/>
-                                        <p:tgtEl>
-                                          <p:spTgt spid="26">
-                                            <p:txEl>
-                                              <p:pRg st="11" end="11"/>
-                                            </p:txEl>
-                                          </p:spTgt>
-                                        </p:tgtEl>
-                                      </p:cBhvr>
-                                    </p:animEffect>
-                                  </p:childTnLst>
-                                </p:cTn>
-                              </p:par>
-                              <p:par>
-                                <p:cTn id="47" presetID="21" presetClass="entr" presetSubtype="1" fill="hold" nodeType="withEffect">
-                                  <p:stCondLst>
-                                    <p:cond delay="0"/>
-                                  </p:stCondLst>
-                                  <p:childTnLst>
-                                    <p:set>
-                                      <p:cBhvr>
-                                        <p:cTn id="48" dur="1" fill="hold">
-                                          <p:stCondLst>
-                                            <p:cond delay="0"/>
-                                          </p:stCondLst>
-                                        </p:cTn>
-                                        <p:tgtEl>
-                                          <p:spTgt spid="26">
-                                            <p:txEl>
-                                              <p:pRg st="12" end="12"/>
-                                            </p:txEl>
-                                          </p:spTgt>
-                                        </p:tgtEl>
-                                        <p:attrNameLst>
-                                          <p:attrName>style.visibility</p:attrName>
-                                        </p:attrNameLst>
-                                      </p:cBhvr>
-                                      <p:to>
-                                        <p:strVal val="visible"/>
-                                      </p:to>
-                                    </p:set>
-                                    <p:animEffect transition="in" filter="wheel(1)">
-                                      <p:cBhvr>
-                                        <p:cTn id="49" dur="2000"/>
-                                        <p:tgtEl>
-                                          <p:spTgt spid="26">
-                                            <p:txEl>
-                                              <p:pRg st="12" end="12"/>
-                                            </p:txEl>
-                                          </p:spTgt>
-                                        </p:tgtEl>
-                                      </p:cBhvr>
-                                    </p:animEffect>
-                                  </p:childTnLst>
-                                </p:cTn>
-                              </p:par>
-                              <p:par>
-                                <p:cTn id="50" presetID="21" presetClass="entr" presetSubtype="1" fill="hold" nodeType="withEffect">
-                                  <p:stCondLst>
-                                    <p:cond delay="0"/>
-                                  </p:stCondLst>
-                                  <p:childTnLst>
-                                    <p:set>
-                                      <p:cBhvr>
-                                        <p:cTn id="51" dur="1" fill="hold">
-                                          <p:stCondLst>
-                                            <p:cond delay="0"/>
-                                          </p:stCondLst>
-                                        </p:cTn>
-                                        <p:tgtEl>
-                                          <p:spTgt spid="26">
-                                            <p:txEl>
-                                              <p:pRg st="13" end="13"/>
-                                            </p:txEl>
-                                          </p:spTgt>
-                                        </p:tgtEl>
-                                        <p:attrNameLst>
-                                          <p:attrName>style.visibility</p:attrName>
-                                        </p:attrNameLst>
-                                      </p:cBhvr>
-                                      <p:to>
-                                        <p:strVal val="visible"/>
-                                      </p:to>
-                                    </p:set>
-                                    <p:animEffect transition="in" filter="wheel(1)">
-                                      <p:cBhvr>
-                                        <p:cTn id="52" dur="2000"/>
-                                        <p:tgtEl>
-                                          <p:spTgt spid="26">
-                                            <p:txEl>
-                                              <p:pRg st="13" end="13"/>
-                                            </p:txEl>
-                                          </p:spTgt>
-                                        </p:tgtEl>
-                                      </p:cBhvr>
-                                    </p:animEffect>
-                                  </p:childTnLst>
-                                </p:cTn>
-                              </p:par>
-                              <p:par>
-                                <p:cTn id="53" presetID="21" presetClass="entr" presetSubtype="1" fill="hold" nodeType="withEffect">
-                                  <p:stCondLst>
-                                    <p:cond delay="0"/>
-                                  </p:stCondLst>
-                                  <p:childTnLst>
-                                    <p:set>
-                                      <p:cBhvr>
-                                        <p:cTn id="54" dur="1" fill="hold">
-                                          <p:stCondLst>
-                                            <p:cond delay="0"/>
-                                          </p:stCondLst>
-                                        </p:cTn>
-                                        <p:tgtEl>
-                                          <p:spTgt spid="26">
-                                            <p:txEl>
-                                              <p:pRg st="14" end="14"/>
-                                            </p:txEl>
-                                          </p:spTgt>
-                                        </p:tgtEl>
-                                        <p:attrNameLst>
-                                          <p:attrName>style.visibility</p:attrName>
-                                        </p:attrNameLst>
-                                      </p:cBhvr>
-                                      <p:to>
-                                        <p:strVal val="visible"/>
-                                      </p:to>
-                                    </p:set>
-                                    <p:animEffect transition="in" filter="wheel(1)">
-                                      <p:cBhvr>
-                                        <p:cTn id="55" dur="2000"/>
-                                        <p:tgtEl>
-                                          <p:spTgt spid="26">
-                                            <p:txEl>
-                                              <p:pRg st="14" end="14"/>
-                                            </p:txEl>
-                                          </p:spTgt>
-                                        </p:tgtEl>
-                                      </p:cBhvr>
-                                    </p:animEffect>
-                                  </p:childTnLst>
-                                </p:cTn>
-                              </p:par>
-                              <p:par>
-                                <p:cTn id="56" presetID="21" presetClass="entr" presetSubtype="1" fill="hold" nodeType="withEffect">
-                                  <p:stCondLst>
-                                    <p:cond delay="0"/>
-                                  </p:stCondLst>
-                                  <p:childTnLst>
-                                    <p:set>
-                                      <p:cBhvr>
-                                        <p:cTn id="57" dur="1" fill="hold">
-                                          <p:stCondLst>
-                                            <p:cond delay="0"/>
-                                          </p:stCondLst>
-                                        </p:cTn>
-                                        <p:tgtEl>
-                                          <p:spTgt spid="26">
-                                            <p:txEl>
-                                              <p:pRg st="15" end="15"/>
-                                            </p:txEl>
-                                          </p:spTgt>
-                                        </p:tgtEl>
-                                        <p:attrNameLst>
-                                          <p:attrName>style.visibility</p:attrName>
-                                        </p:attrNameLst>
-                                      </p:cBhvr>
-                                      <p:to>
-                                        <p:strVal val="visible"/>
-                                      </p:to>
-                                    </p:set>
-                                    <p:animEffect transition="in" filter="wheel(1)">
-                                      <p:cBhvr>
-                                        <p:cTn id="58" dur="2000"/>
-                                        <p:tgtEl>
-                                          <p:spTgt spid="26">
-                                            <p:txEl>
-                                              <p:pRg st="15" end="15"/>
-                                            </p:txEl>
-                                          </p:spTgt>
-                                        </p:tgtEl>
-                                      </p:cBhvr>
-                                    </p:animEffect>
-                                  </p:childTnLst>
-                                </p:cTn>
-                              </p:par>
-                              <p:par>
-                                <p:cTn id="59" presetID="21" presetClass="entr" presetSubtype="1" fill="hold" nodeType="withEffect">
-                                  <p:stCondLst>
-                                    <p:cond delay="0"/>
-                                  </p:stCondLst>
-                                  <p:childTnLst>
-                                    <p:set>
-                                      <p:cBhvr>
-                                        <p:cTn id="60" dur="1" fill="hold">
-                                          <p:stCondLst>
-                                            <p:cond delay="0"/>
-                                          </p:stCondLst>
-                                        </p:cTn>
-                                        <p:tgtEl>
-                                          <p:spTgt spid="26">
-                                            <p:txEl>
-                                              <p:pRg st="16" end="16"/>
-                                            </p:txEl>
-                                          </p:spTgt>
-                                        </p:tgtEl>
-                                        <p:attrNameLst>
-                                          <p:attrName>style.visibility</p:attrName>
-                                        </p:attrNameLst>
-                                      </p:cBhvr>
-                                      <p:to>
-                                        <p:strVal val="visible"/>
-                                      </p:to>
-                                    </p:set>
-                                    <p:animEffect transition="in" filter="wheel(1)">
-                                      <p:cBhvr>
-                                        <p:cTn id="61" dur="2000"/>
-                                        <p:tgtEl>
-                                          <p:spTgt spid="26">
-                                            <p:txEl>
-                                              <p:pRg st="16" end="16"/>
-                                            </p:txEl>
-                                          </p:spTgt>
-                                        </p:tgtEl>
-                                      </p:cBhvr>
-                                    </p:animEffect>
                                   </p:childTnLst>
                                 </p:cTn>
                               </p:par>
@@ -11643,7 +10779,7 @@
         </p:nvSpPr>
         <p:spPr>
           <a:xfrm>
-            <a:off x="139767" y="687300"/>
+            <a:off x="204078" y="79942"/>
             <a:ext cx="8520600" cy="338514"/>
           </a:xfrm>
           <a:prstGeom prst="rect">
@@ -11892,7 +11028,7 @@
               <a:buSzPts val="2800"/>
             </a:pPr>
             <a:r>
-              <a:rPr lang="en-US" sz="1600" b="1">
+              <a:rPr lang="en-US" sz="1600" b="1" dirty="0">
                 <a:solidFill>
                   <a:srgbClr val="002060"/>
                 </a:solidFill>
@@ -12265,36 +11401,59 @@
           </p:spPr>
         </p:pic>
       </p:grpSp>
-      <p:pic>
-        <p:nvPicPr>
-          <p:cNvPr id="4" name="Picture 3">
+      <p:sp>
+        <p:nvSpPr>
+          <p:cNvPr id="2" name="Rectangle 1">
             <a:extLst>
               <a:ext uri="{FF2B5EF4-FFF2-40B4-BE49-F238E27FC236}">
-                <a16:creationId xmlns:a16="http://schemas.microsoft.com/office/drawing/2014/main" id="{38869DEC-3AC7-E164-AE02-550E3E885B4E}"/>
+                <a16:creationId xmlns:a16="http://schemas.microsoft.com/office/drawing/2014/main" id="{9D16D08D-D631-0BB7-65EF-CC5D3A6A43B9}"/>
               </a:ext>
             </a:extLst>
           </p:cNvPr>
-          <p:cNvPicPr>
-            <a:picLocks noChangeAspect="1"/>
-          </p:cNvPicPr>
+          <p:cNvSpPr/>
           <p:nvPr/>
-        </p:nvPicPr>
-        <p:blipFill>
-          <a:blip r:embed="rId5"/>
-          <a:stretch>
-            <a:fillRect/>
-          </a:stretch>
-        </p:blipFill>
+        </p:nvSpPr>
         <p:spPr>
           <a:xfrm>
-            <a:off x="2650539" y="3535880"/>
-            <a:ext cx="4197350" cy="1073150"/>
+            <a:off x="2238451" y="3599255"/>
+            <a:ext cx="4835348" cy="584775"/>
           </a:xfrm>
           <a:prstGeom prst="rect">
             <a:avLst/>
           </a:prstGeom>
+          <a:noFill/>
         </p:spPr>
-      </p:pic>
+        <p:txBody>
+          <a:bodyPr wrap="square" lIns="91440" tIns="45720" rIns="91440" bIns="45720">
+            <a:spAutoFit/>
+          </a:bodyPr>
+          <a:lstStyle/>
+          <a:p>
+            <a:pPr algn="ctr"/>
+            <a:r>
+              <a:rPr lang="en-US" sz="1600" dirty="0">
+                <a:solidFill>
+                  <a:schemeClr val="tx1"/>
+                </a:solidFill>
+              </a:rPr>
+              <a:t>https://final-capston-project-finance-generative-ai-kddkwfgmcs9synbfbb.streamlit.app</a:t>
+            </a:r>
+            <a:endParaRPr lang="en-US" sz="1600" b="0" cap="none" spc="0" dirty="0">
+              <a:ln w="0"/>
+              <a:solidFill>
+                <a:schemeClr val="tx1"/>
+              </a:solidFill>
+              <a:effectLst>
+                <a:outerShdw blurRad="38100" dist="19050" dir="2700000" algn="tl" rotWithShape="0">
+                  <a:schemeClr val="dk1">
+                    <a:alpha val="40000"/>
+                  </a:schemeClr>
+                </a:outerShdw>
+              </a:effectLst>
+            </a:endParaRPr>
+          </a:p>
+        </p:txBody>
+      </p:sp>
     </p:spTree>
     <p:extLst>
       <p:ext uri="{BB962C8B-B14F-4D97-AF65-F5344CB8AC3E}">
@@ -12415,33 +11574,173 @@
                       </p:childTnLst>
                     </p:cTn>
                   </p:par>
+                </p:childTnLst>
+              </p:cTn>
+              <p:prevCondLst>
+                <p:cond evt="onPrev" delay="0">
+                  <p:tgtEl>
+                    <p:sldTgt/>
+                  </p:tgtEl>
+                </p:cond>
+              </p:prevCondLst>
+              <p:nextCondLst>
+                <p:cond evt="onNext" delay="0">
+                  <p:tgtEl>
+                    <p:sldTgt/>
+                  </p:tgtEl>
+                </p:cond>
+              </p:nextCondLst>
+            </p:seq>
+          </p:childTnLst>
+        </p:cTn>
+      </p:par>
+    </p:tnLst>
+  </p:timing>
+</p:sld>
+</file>
+
+<file path=ppt/slides/slide5.xml><?xml version="1.0" encoding="utf-8"?>
+<p:sld xmlns:a="http://schemas.openxmlformats.org/drawingml/2006/main" xmlns:r="http://schemas.openxmlformats.org/officeDocument/2006/relationships" xmlns:p="http://schemas.openxmlformats.org/presentationml/2006/main">
+  <p:cSld>
+    <p:spTree>
+      <p:nvGrpSpPr>
+        <p:cNvPr id="1" name=""/>
+        <p:cNvGrpSpPr/>
+        <p:nvPr/>
+      </p:nvGrpSpPr>
+      <p:grpSpPr>
+        <a:xfrm>
+          <a:off x="0" y="0"/>
+          <a:ext cx="0" cy="0"/>
+          <a:chOff x="0" y="0"/>
+          <a:chExt cx="0" cy="0"/>
+        </a:xfrm>
+      </p:grpSpPr>
+      <p:sp>
+        <p:nvSpPr>
+          <p:cNvPr id="3" name="TextBox 2">
+            <a:extLst>
+              <a:ext uri="{FF2B5EF4-FFF2-40B4-BE49-F238E27FC236}">
+                <a16:creationId xmlns:a16="http://schemas.microsoft.com/office/drawing/2014/main" id="{8A27824B-B1F1-5F97-A9B5-55C08BBBBBF7}"/>
+              </a:ext>
+            </a:extLst>
+          </p:cNvPr>
+          <p:cNvSpPr txBox="1"/>
+          <p:nvPr/>
+        </p:nvSpPr>
+        <p:spPr>
+          <a:xfrm>
+            <a:off x="179223" y="98487"/>
+            <a:ext cx="4572000" cy="307777"/>
+          </a:xfrm>
+          <a:prstGeom prst="rect">
+            <a:avLst/>
+          </a:prstGeom>
+          <a:noFill/>
+        </p:spPr>
+        <p:txBody>
+          <a:bodyPr wrap="square">
+            <a:spAutoFit/>
+          </a:bodyPr>
+          <a:lstStyle/>
+          <a:p>
+            <a:r>
+              <a:rPr lang="en-US" sz="1400" b="1" dirty="0">
+                <a:solidFill>
+                  <a:srgbClr val="002060"/>
+                </a:solidFill>
+                <a:latin typeface="Arial"/>
+                <a:ea typeface="Arial"/>
+                <a:cs typeface="Arial"/>
+                <a:sym typeface="Arial"/>
+              </a:rPr>
+              <a:t>Output </a:t>
+            </a:r>
+            <a:endParaRPr lang="en-IN" sz="1400" dirty="0">
+              <a:solidFill>
+                <a:srgbClr val="213163"/>
+              </a:solidFill>
+            </a:endParaRPr>
+          </a:p>
+        </p:txBody>
+      </p:sp>
+      <p:pic>
+        <p:nvPicPr>
+          <p:cNvPr id="5" name="Picture 4">
+            <a:extLst>
+              <a:ext uri="{FF2B5EF4-FFF2-40B4-BE49-F238E27FC236}">
+                <a16:creationId xmlns:a16="http://schemas.microsoft.com/office/drawing/2014/main" id="{B882905D-F1E0-3DEE-0B83-0121036FF7A5}"/>
+              </a:ext>
+            </a:extLst>
+          </p:cNvPr>
+          <p:cNvPicPr>
+            <a:picLocks noChangeAspect="1"/>
+          </p:cNvPicPr>
+          <p:nvPr/>
+        </p:nvPicPr>
+        <p:blipFill>
+          <a:blip r:embed="rId2"/>
+          <a:srcRect/>
+          <a:stretch/>
+        </p:blipFill>
+        <p:spPr>
+          <a:xfrm>
+            <a:off x="795835" y="573122"/>
+            <a:ext cx="7770649" cy="4370991"/>
+          </a:xfrm>
+          <a:prstGeom prst="rect">
+            <a:avLst/>
+          </a:prstGeom>
+        </p:spPr>
+      </p:pic>
+    </p:spTree>
+    <p:extLst>
+      <p:ext uri="{BB962C8B-B14F-4D97-AF65-F5344CB8AC3E}">
+        <p14:creationId xmlns:p14="http://schemas.microsoft.com/office/powerpoint/2010/main" val="3672942402"/>
+      </p:ext>
+    </p:extLst>
+  </p:cSld>
+  <p:clrMapOvr>
+    <a:masterClrMapping/>
+  </p:clrMapOvr>
+  <p:transition spd="slow">
+    <p:push dir="u"/>
+  </p:transition>
+  <p:timing>
+    <p:tnLst>
+      <p:par>
+        <p:cTn id="1" dur="indefinite" restart="never" nodeType="tmRoot">
+          <p:childTnLst>
+            <p:seq concurrent="1" nextAc="seek">
+              <p:cTn id="2" dur="indefinite" nodeType="mainSeq">
+                <p:childTnLst>
                   <p:par>
-                    <p:cTn id="10" fill="hold">
+                    <p:cTn id="3" fill="hold">
                       <p:stCondLst>
                         <p:cond delay="indefinite"/>
                       </p:stCondLst>
                       <p:childTnLst>
                         <p:par>
-                          <p:cTn id="11" fill="hold">
+                          <p:cTn id="4" fill="hold">
                             <p:stCondLst>
                               <p:cond delay="0"/>
                             </p:stCondLst>
                             <p:childTnLst>
                               <p:par>
-                                <p:cTn id="12" presetID="42" presetClass="entr" presetSubtype="0" fill="hold" nodeType="clickEffect">
+                                <p:cTn id="5" presetID="16" presetClass="entr" presetSubtype="21" fill="hold" nodeType="clickEffect">
                                   <p:stCondLst>
                                     <p:cond delay="0"/>
                                   </p:stCondLst>
                                   <p:childTnLst>
                                     <p:set>
                                       <p:cBhvr>
-                                        <p:cTn id="13" dur="1" fill="hold">
+                                        <p:cTn id="6" dur="1" fill="hold">
                                           <p:stCondLst>
                                             <p:cond delay="0"/>
                                           </p:stCondLst>
                                         </p:cTn>
                                         <p:tgtEl>
-                                          <p:spTgt spid="4"/>
+                                          <p:spTgt spid="5"/>
                                         </p:tgtEl>
                                         <p:attrNameLst>
                                           <p:attrName>style.visibility</p:attrName>
@@ -12451,60 +11750,14 @@
                                         <p:strVal val="visible"/>
                                       </p:to>
                                     </p:set>
-                                    <p:animEffect transition="in" filter="fade">
-                                      <p:cBhvr>
-                                        <p:cTn id="14" dur="1000"/>
-                                        <p:tgtEl>
-                                          <p:spTgt spid="4"/>
+                                    <p:animEffect transition="in" filter="barn(inVertical)">
+                                      <p:cBhvr>
+                                        <p:cTn id="7" dur="500"/>
+                                        <p:tgtEl>
+                                          <p:spTgt spid="5"/>
                                         </p:tgtEl>
                                       </p:cBhvr>
                                     </p:animEffect>
-                                    <p:anim calcmode="lin" valueType="num">
-                                      <p:cBhvr>
-                                        <p:cTn id="15" dur="1000" fill="hold"/>
-                                        <p:tgtEl>
-                                          <p:spTgt spid="4"/>
-                                        </p:tgtEl>
-                                        <p:attrNameLst>
-                                          <p:attrName>ppt_x</p:attrName>
-                                        </p:attrNameLst>
-                                      </p:cBhvr>
-                                      <p:tavLst>
-                                        <p:tav tm="0">
-                                          <p:val>
-                                            <p:strVal val="#ppt_x"/>
-                                          </p:val>
-                                        </p:tav>
-                                        <p:tav tm="100000">
-                                          <p:val>
-                                            <p:strVal val="#ppt_x"/>
-                                          </p:val>
-                                        </p:tav>
-                                      </p:tavLst>
-                                    </p:anim>
-                                    <p:anim calcmode="lin" valueType="num">
-                                      <p:cBhvr>
-                                        <p:cTn id="16" dur="1000" fill="hold"/>
-                                        <p:tgtEl>
-                                          <p:spTgt spid="4"/>
-                                        </p:tgtEl>
-                                        <p:attrNameLst>
-                                          <p:attrName>ppt_y</p:attrName>
-                                        </p:attrNameLst>
-                                      </p:cBhvr>
-                                      <p:tavLst>
-                                        <p:tav tm="0">
-                                          <p:val>
-                                            <p:strVal val="#ppt_y+.1"/>
-                                          </p:val>
-                                        </p:tav>
-                                        <p:tav tm="100000">
-                                          <p:val>
-                                            <p:strVal val="#ppt_y"/>
-                                          </p:val>
-                                        </p:tav>
-                                      </p:tavLst>
-                                    </p:anim>
                                   </p:childTnLst>
                                 </p:cTn>
                               </p:par>
@@ -12539,7 +11792,7 @@
 </p:sld>
 </file>
 
-<file path=ppt/slides/slide5.xml><?xml version="1.0" encoding="utf-8"?>
+<file path=ppt/slides/slide6.xml><?xml version="1.0" encoding="utf-8"?>
 <p:sld xmlns:a="http://schemas.openxmlformats.org/drawingml/2006/main" xmlns:r="http://schemas.openxmlformats.org/officeDocument/2006/relationships" xmlns:p="http://schemas.openxmlformats.org/presentationml/2006/main">
   <p:cSld>
     <p:spTree>
@@ -13073,13 +12326,13 @@
   <p:clrMapOvr>
     <a:masterClrMapping/>
   </p:clrMapOvr>
-  <mc:AlternateContent xmlns:mc="http://schemas.openxmlformats.org/markup-compatibility/2006">
-    <mc:Choice xmlns:p159="http://schemas.microsoft.com/office/powerpoint/2015/09/main" Requires="p159">
+  <mc:AlternateContent xmlns:mc="http://schemas.openxmlformats.org/markup-compatibility/2006" xmlns:p159="http://schemas.microsoft.com/office/powerpoint/2015/09/main">
+    <mc:Choice Requires="p159">
       <p:transition xmlns:p14="http://schemas.microsoft.com/office/powerpoint/2010/main" spd="slow" p14:dur="2000">
         <p159:morph option="byObject"/>
       </p:transition>
     </mc:Choice>
-    <mc:Fallback>
+    <mc:Fallback xmlns="">
       <p:transition spd="slow">
         <p:fade/>
       </p:transition>
@@ -13212,7 +12465,7 @@
 </p:sld>
 </file>
 
-<file path=ppt/slides/slide6.xml><?xml version="1.0" encoding="utf-8"?>
+<file path=ppt/slides/slide7.xml><?xml version="1.0" encoding="utf-8"?>
 <p:sld xmlns:a="http://schemas.openxmlformats.org/drawingml/2006/main" xmlns:r="http://schemas.openxmlformats.org/officeDocument/2006/relationships" xmlns:p="http://schemas.openxmlformats.org/presentationml/2006/main">
   <p:cSld>
     <p:spTree>
@@ -13572,23 +12825,7 @@
                   <a:schemeClr val="tx1"/>
                 </a:solidFill>
               </a:rPr>
-              <a:t>Real-time stock data via </a:t>
-            </a:r>
-            <a:r>
-              <a:rPr lang="en-US" dirty="0" err="1">
-                <a:solidFill>
-                  <a:schemeClr val="tx1"/>
-                </a:solidFill>
-              </a:rPr>
-              <a:t>yFinance</a:t>
-            </a:r>
-            <a:r>
-              <a:rPr lang="en-US" dirty="0">
-                <a:solidFill>
-                  <a:schemeClr val="tx1"/>
-                </a:solidFill>
-              </a:rPr>
-              <a:t> API.</a:t>
+              <a:t>Real-time stock data via yFinance API.</a:t>
             </a:r>
           </a:p>
           <a:p>
@@ -13786,13 +13023,13 @@
   <p:clrMapOvr>
     <a:masterClrMapping/>
   </p:clrMapOvr>
-  <mc:AlternateContent xmlns:mc="http://schemas.openxmlformats.org/markup-compatibility/2006">
-    <mc:Choice xmlns:p159="http://schemas.microsoft.com/office/powerpoint/2015/09/main" Requires="p159">
+  <mc:AlternateContent xmlns:mc="http://schemas.openxmlformats.org/markup-compatibility/2006" xmlns:p159="http://schemas.microsoft.com/office/powerpoint/2015/09/main">
+    <mc:Choice Requires="p159">
       <p:transition xmlns:p14="http://schemas.microsoft.com/office/powerpoint/2010/main" spd="slow" p14:dur="2000">
         <p159:morph option="byObject"/>
       </p:transition>
     </mc:Choice>
-    <mc:Fallback>
+    <mc:Fallback xmlns="">
       <p:transition spd="slow">
         <p:fade/>
       </p:transition>
@@ -13887,7 +13124,7 @@
 </p:sld>
 </file>
 
-<file path=ppt/slides/slide7.xml><?xml version="1.0" encoding="utf-8"?>
+<file path=ppt/slides/slide8.xml><?xml version="1.0" encoding="utf-8"?>
 <p:sld xmlns:a="http://schemas.openxmlformats.org/drawingml/2006/main" xmlns:r="http://schemas.openxmlformats.org/officeDocument/2006/relationships" xmlns:p="http://schemas.openxmlformats.org/presentationml/2006/main">
   <p:cSld>
     <p:spTree>
@@ -13925,7 +13162,7 @@
         </p:blipFill>
         <p:spPr>
           <a:xfrm>
-            <a:off x="2062382" y="687712"/>
+            <a:off x="1667361" y="1039507"/>
             <a:ext cx="5647194" cy="3064485"/>
           </a:xfrm>
           <a:prstGeom prst="rect">
@@ -13948,7 +13185,7 @@
         <p:spPr>
           <a:xfrm>
             <a:off x="1576522" y="2923545"/>
-            <a:ext cx="6564178" cy="307777"/>
+            <a:ext cx="6564178" cy="584775"/>
           </a:xfrm>
           <a:prstGeom prst="rect">
             <a:avLst/>
@@ -13961,6 +13198,13 @@
           </a:bodyPr>
           <a:lstStyle/>
           <a:p>
+            <a:pPr algn="ctr"/>
+            <a:r>
+              <a:rPr lang="en-US" sz="1800" b="1" dirty="0"/>
+              <a:t>AI STOCK PRO INTELLIGENCE</a:t>
+            </a:r>
+          </a:p>
+          <a:p>
             <a:pPr marL="0" indent="0" algn="ctr">
               <a:buNone/>
             </a:pPr>
@@ -13972,7 +13216,7 @@
                 <a:latin typeface="Dubai" panose="020B0503030403030204" pitchFamily="34" charset="-78"/>
                 <a:cs typeface="Dubai" panose="020B0503030403030204" pitchFamily="34" charset="-78"/>
               </a:rPr>
-              <a:t>Smart Stock Market Analyst  •  Generative AI  Final Capstone Project</a:t>
+              <a:t>Generative AI  Final Capstone Project</a:t>
             </a:r>
             <a:endParaRPr lang="en-US" b="1" i="1" dirty="0">
               <a:latin typeface="Dubai" panose="020B0503030403030204" pitchFamily="34" charset="-78"/>
@@ -14015,6 +13259,13 @@
             <a:prstDash val="solid"/>
           </a:ln>
         </p:spPr>
+        <p:txBody>
+          <a:bodyPr/>
+          <a:lstStyle/>
+          <a:p>
+            <a:endParaRPr lang="en-US"/>
+          </a:p>
+        </p:txBody>
       </p:sp>
       <p:sp>
         <p:nvSpPr>
@@ -14092,6 +13343,13 @@
             <a:prstDash val="solid"/>
           </a:ln>
         </p:spPr>
+        <p:txBody>
+          <a:bodyPr/>
+          <a:lstStyle/>
+          <a:p>
+            <a:endParaRPr lang="en-US"/>
+          </a:p>
+        </p:txBody>
       </p:sp>
       <p:sp>
         <p:nvSpPr>
@@ -14169,6 +13427,13 @@
             <a:prstDash val="solid"/>
           </a:ln>
         </p:spPr>
+        <p:txBody>
+          <a:bodyPr/>
+          <a:lstStyle/>
+          <a:p>
+            <a:endParaRPr lang="en-US"/>
+          </a:p>
+        </p:txBody>
       </p:sp>
       <p:sp>
         <p:nvSpPr>
@@ -14246,6 +13511,13 @@
             <a:prstDash val="solid"/>
           </a:ln>
         </p:spPr>
+        <p:txBody>
+          <a:bodyPr/>
+          <a:lstStyle/>
+          <a:p>
+            <a:endParaRPr lang="en-US"/>
+          </a:p>
+        </p:txBody>
       </p:sp>
       <p:sp>
         <p:nvSpPr>
@@ -14323,6 +13595,13 @@
             <a:prstDash val="solid"/>
           </a:ln>
         </p:spPr>
+        <p:txBody>
+          <a:bodyPr/>
+          <a:lstStyle/>
+          <a:p>
+            <a:endParaRPr lang="en-US"/>
+          </a:p>
+        </p:txBody>
       </p:sp>
       <p:sp>
         <p:nvSpPr>
@@ -14422,13 +13701,13 @@
   <p:clrMapOvr>
     <a:masterClrMapping/>
   </p:clrMapOvr>
-  <mc:AlternateContent xmlns:mc="http://schemas.openxmlformats.org/markup-compatibility/2006">
-    <mc:Choice xmlns:p159="http://schemas.microsoft.com/office/powerpoint/2015/09/main" Requires="p159">
+  <mc:AlternateContent xmlns:mc="http://schemas.openxmlformats.org/markup-compatibility/2006" xmlns:p159="http://schemas.microsoft.com/office/powerpoint/2015/09/main">
+    <mc:Choice Requires="p159">
       <p:transition xmlns:p14="http://schemas.microsoft.com/office/powerpoint/2010/main" spd="slow" p14:dur="2000">
         <p159:morph option="byObject"/>
       </p:transition>
     </mc:Choice>
-    <mc:Fallback>
+    <mc:Fallback xmlns="">
       <p:transition spd="slow">
         <p:fade/>
       </p:transition>
@@ -14455,20 +13734,122 @@
                             </p:stCondLst>
                             <p:childTnLst>
                               <p:par>
-                                <p:cTn id="5" presetID="45" presetClass="entr" presetSubtype="0" fill="hold" nodeType="clickEffect">
+                                <p:cTn id="5" presetID="32" presetClass="emph" presetSubtype="0" fill="hold" nodeType="clickEffect">
+                                  <p:stCondLst>
+                                    <p:cond delay="0"/>
+                                  </p:stCondLst>
+                                  <p:childTnLst>
+                                    <p:animRot by="120000">
+                                      <p:cBhvr>
+                                        <p:cTn id="6" dur="100" fill="hold">
+                                          <p:stCondLst>
+                                            <p:cond delay="0"/>
+                                          </p:stCondLst>
+                                        </p:cTn>
+                                        <p:tgtEl>
+                                          <p:spTgt spid="10"/>
+                                        </p:tgtEl>
+                                        <p:attrNameLst>
+                                          <p:attrName>r</p:attrName>
+                                        </p:attrNameLst>
+                                      </p:cBhvr>
+                                    </p:animRot>
+                                    <p:animRot by="-240000">
+                                      <p:cBhvr>
+                                        <p:cTn id="7" dur="200" fill="hold">
+                                          <p:stCondLst>
+                                            <p:cond delay="200"/>
+                                          </p:stCondLst>
+                                        </p:cTn>
+                                        <p:tgtEl>
+                                          <p:spTgt spid="10"/>
+                                        </p:tgtEl>
+                                        <p:attrNameLst>
+                                          <p:attrName>r</p:attrName>
+                                        </p:attrNameLst>
+                                      </p:cBhvr>
+                                    </p:animRot>
+                                    <p:animRot by="240000">
+                                      <p:cBhvr>
+                                        <p:cTn id="8" dur="200" fill="hold">
+                                          <p:stCondLst>
+                                            <p:cond delay="400"/>
+                                          </p:stCondLst>
+                                        </p:cTn>
+                                        <p:tgtEl>
+                                          <p:spTgt spid="10"/>
+                                        </p:tgtEl>
+                                        <p:attrNameLst>
+                                          <p:attrName>r</p:attrName>
+                                        </p:attrNameLst>
+                                      </p:cBhvr>
+                                    </p:animRot>
+                                    <p:animRot by="-240000">
+                                      <p:cBhvr>
+                                        <p:cTn id="9" dur="200" fill="hold">
+                                          <p:stCondLst>
+                                            <p:cond delay="600"/>
+                                          </p:stCondLst>
+                                        </p:cTn>
+                                        <p:tgtEl>
+                                          <p:spTgt spid="10"/>
+                                        </p:tgtEl>
+                                        <p:attrNameLst>
+                                          <p:attrName>r</p:attrName>
+                                        </p:attrNameLst>
+                                      </p:cBhvr>
+                                    </p:animRot>
+                                    <p:animRot by="120000">
+                                      <p:cBhvr>
+                                        <p:cTn id="10" dur="200" fill="hold">
+                                          <p:stCondLst>
+                                            <p:cond delay="800"/>
+                                          </p:stCondLst>
+                                        </p:cTn>
+                                        <p:tgtEl>
+                                          <p:spTgt spid="10"/>
+                                        </p:tgtEl>
+                                        <p:attrNameLst>
+                                          <p:attrName>r</p:attrName>
+                                        </p:attrNameLst>
+                                      </p:cBhvr>
+                                    </p:animRot>
+                                  </p:childTnLst>
+                                </p:cTn>
+                              </p:par>
+                            </p:childTnLst>
+                          </p:cTn>
+                        </p:par>
+                      </p:childTnLst>
+                    </p:cTn>
+                  </p:par>
+                  <p:par>
+                    <p:cTn id="11" fill="hold">
+                      <p:stCondLst>
+                        <p:cond delay="indefinite"/>
+                      </p:stCondLst>
+                      <p:childTnLst>
+                        <p:par>
+                          <p:cTn id="12" fill="hold">
+                            <p:stCondLst>
+                              <p:cond delay="0"/>
+                            </p:stCondLst>
+                            <p:childTnLst>
+                              <p:par>
+                                <p:cTn id="13" presetID="2" presetClass="entr" presetSubtype="4" fill="hold" nodeType="clickEffect">
                                   <p:stCondLst>
                                     <p:cond delay="0"/>
                                   </p:stCondLst>
                                   <p:childTnLst>
                                     <p:set>
                                       <p:cBhvr>
-                                        <p:cTn id="6" dur="1" fill="hold">
+                                        <p:cTn id="14" dur="1" fill="hold">
                                           <p:stCondLst>
                                             <p:cond delay="0"/>
                                           </p:stCondLst>
                                         </p:cTn>
                                         <p:tgtEl>
-                                          <p:spTgt spid="10"/>
+                                          <p:spTgt spid="4"/>
                                         </p:tgtEl>
                                         <p:attrNameLst>
                                           <p:attrName>style.visibility</p:attrName>
@@ -14478,56 +13859,48 @@
                                         <p:strVal val="visible"/>
                                       </p:to>
                                     </p:set>
-                                    <p:animEffect transition="in" filter="fade">
-                                      <p:cBhvr>
-                                        <p:cTn id="7" dur="2000"/>
-                                        <p:tgtEl>
-                                          <p:spTgt spid="10"/>
-                                        </p:tgtEl>
-                                      </p:cBhvr>
-                                    </p:animEffect>
                                     <p:anim calcmode="lin" valueType="num">
-                                      <p:cBhvr>
-                                        <p:cTn id="8" dur="2000" fill="hold"/>
-                                        <p:tgtEl>
-                                          <p:spTgt spid="10"/>
+                                      <p:cBhvr additive="base">
+                                        <p:cTn id="15" dur="500" fill="hold"/>
+                                        <p:tgtEl>
+                                          <p:spTgt spid="4"/>
                                         </p:tgtEl>
                                         <p:attrNameLst>
-                                          <p:attrName>ppt_w</p:attrName>
+                                          <p:attrName>ppt_x</p:attrName>
                                         </p:attrNameLst>
                                       </p:cBhvr>
                                       <p:tavLst>
-                                        <p:tav tm="0" fmla="#ppt_w*sin(2.5*pi*$)">
-                                          <p:val>
-                                            <p:fltVal val="0"/>
+                                        <p:tav tm="0">
+                                          <p:val>
+                                            <p:strVal val="#ppt_x"/>
                                           </p:val>
                                         </p:tav>
                                         <p:tav tm="100000">
                                           <p:val>
-                                            <p:fltVal val="1"/>
+                                            <p:strVal val="#ppt_x"/>
                                           </p:val>
                                         </p:tav>
                                       </p:tavLst>
                                     </p:anim>
                                     <p:anim calcmode="lin" valueType="num">
-                                      <p:cBhvr>
-                                        <p:cTn id="9" dur="2000" fill="hold"/>
-                                        <p:tgtEl>
-                                          <p:spTgt spid="10"/>
+                                      <p:cBhvr additive="base">
+                                        <p:cTn id="16" dur="500" fill="hold"/>
+                                        <p:tgtEl>
+                                          <p:spTgt spid="4"/>
                                         </p:tgtEl>
                                         <p:attrNameLst>
-                                          <p:attrName>ppt_h</p:attrName>
+                                          <p:attrName>ppt_y</p:attrName>
                                         </p:attrNameLst>
                                       </p:cBhvr>
                                       <p:tavLst>
                                         <p:tav tm="0">
                                           <p:val>
-                                            <p:strVal val="#ppt_h"/>
+                                            <p:strVal val="1+#ppt_h/2"/>
                                           </p:val>
                                         </p:tav>
                                         <p:tav tm="100000">
                                           <p:val>
-                                            <p:strVal val="#ppt_h"/>
+                                            <p:strVal val="#ppt_y"/>
                                           </p:val>
                                         </p:tav>
                                       </p:tavLst>
@@ -14542,32 +13915,32 @@
                     </p:cTn>
                   </p:par>
                   <p:par>
-                    <p:cTn id="10" fill="hold">
+                    <p:cTn id="17" fill="hold">
                       <p:stCondLst>
                         <p:cond delay="indefinite"/>
                       </p:stCondLst>
                       <p:childTnLst>
                         <p:par>
-                          <p:cTn id="11" fill="hold">
+                          <p:cTn id="18" fill="hold">
                             <p:stCondLst>
                               <p:cond delay="0"/>
                             </p:stCondLst>
                             <p:childTnLst>
                               <p:par>
-                                <p:cTn id="12" presetID="2" presetClass="entr" presetSubtype="4" fill="hold" nodeType="clickEffect">
+                                <p:cTn id="19" presetID="2" presetClass="entr" presetSubtype="4" fill="hold" grpId="0" nodeType="clickEffect">
                                   <p:stCondLst>
                                     <p:cond delay="0"/>
                                   </p:stCondLst>
                                   <p:childTnLst>
                                     <p:set>
                                       <p:cBhvr>
-                                        <p:cTn id="13" dur="1" fill="hold">
+                                        <p:cTn id="20" dur="1" fill="hold">
                                           <p:stCondLst>
                                             <p:cond delay="0"/>
                                           </p:stCondLst>
                                         </p:cTn>
                                         <p:tgtEl>
-                                          <p:spTgt spid="4"/>
+                                          <p:spTgt spid="7"/>
                                         </p:tgtEl>
                                         <p:attrNameLst>
                                           <p:attrName>style.visibility</p:attrName>
@@ -14579,9 +13952,9 @@
                                     </p:set>
                                     <p:anim calcmode="lin" valueType="num">
                                       <p:cBhvr additive="base">
-                                        <p:cTn id="14" dur="500" fill="hold"/>
-                                        <p:tgtEl>
-                                          <p:spTgt spid="4"/>
+                                        <p:cTn id="21" dur="500" fill="hold"/>
+                                        <p:tgtEl>
+                                          <p:spTgt spid="7"/>
                                         </p:tgtEl>
                                         <p:attrNameLst>
                                           <p:attrName>ppt_x</p:attrName>
@@ -14602,9 +13975,9 @@
                                     </p:anim>
                                     <p:anim calcmode="lin" valueType="num">
                                       <p:cBhvr additive="base">
-                                        <p:cTn id="15" dur="500" fill="hold"/>
-                                        <p:tgtEl>
-                                          <p:spTgt spid="4"/>
+                                        <p:cTn id="22" dur="500" fill="hold"/>
+                                        <p:tgtEl>
+                                          <p:spTgt spid="7"/>
                                         </p:tgtEl>
                                         <p:attrNameLst>
                                           <p:attrName>ppt_y</p:attrName>
@@ -14633,32 +14006,32 @@
                     </p:cTn>
                   </p:par>
                   <p:par>
-                    <p:cTn id="16" fill="hold">
+                    <p:cTn id="23" fill="hold">
                       <p:stCondLst>
                         <p:cond delay="indefinite"/>
                       </p:stCondLst>
                       <p:childTnLst>
                         <p:par>
-                          <p:cTn id="17" fill="hold">
+                          <p:cTn id="24" fill="hold">
                             <p:stCondLst>
                               <p:cond delay="0"/>
                             </p:stCondLst>
                             <p:childTnLst>
                               <p:par>
-                                <p:cTn id="18" presetID="2" presetClass="entr" presetSubtype="4" fill="hold" grpId="0" nodeType="clickEffect">
+                                <p:cTn id="25" presetID="2" presetClass="entr" presetSubtype="4" fill="hold" nodeType="clickEffect">
                                   <p:stCondLst>
                                     <p:cond delay="0"/>
                                   </p:stCondLst>
                                   <p:childTnLst>
                                     <p:set>
                                       <p:cBhvr>
-                                        <p:cTn id="19" dur="1" fill="hold">
+                                        <p:cTn id="26" dur="1" fill="hold">
                                           <p:stCondLst>
                                             <p:cond delay="0"/>
                                           </p:stCondLst>
                                         </p:cTn>
                                         <p:tgtEl>
-                                          <p:spTgt spid="7"/>
+                                          <p:spTgt spid="8"/>
                                         </p:tgtEl>
                                         <p:attrNameLst>
                                           <p:attrName>style.visibility</p:attrName>
@@ -14670,9 +14043,9 @@
                                     </p:set>
                                     <p:anim calcmode="lin" valueType="num">
                                       <p:cBhvr additive="base">
-                                        <p:cTn id="20" dur="500" fill="hold"/>
-                                        <p:tgtEl>
-                                          <p:spTgt spid="7"/>
+                                        <p:cTn id="27" dur="500" fill="hold"/>
+                                        <p:tgtEl>
+                                          <p:spTgt spid="8"/>
                                         </p:tgtEl>
                                         <p:attrNameLst>
                                           <p:attrName>ppt_x</p:attrName>
@@ -14693,9 +14066,9 @@
                                     </p:anim>
                                     <p:anim calcmode="lin" valueType="num">
                                       <p:cBhvr additive="base">
-                                        <p:cTn id="21" dur="500" fill="hold"/>
-                                        <p:tgtEl>
-                                          <p:spTgt spid="7"/>
+                                        <p:cTn id="28" dur="500" fill="hold"/>
+                                        <p:tgtEl>
+                                          <p:spTgt spid="8"/>
                                         </p:tgtEl>
                                         <p:attrNameLst>
                                           <p:attrName>ppt_y</p:attrName>
@@ -14724,32 +14097,32 @@
                     </p:cTn>
                   </p:par>
                   <p:par>
-                    <p:cTn id="22" fill="hold">
+                    <p:cTn id="29" fill="hold">
                       <p:stCondLst>
                         <p:cond delay="indefinite"/>
                       </p:stCondLst>
                       <p:childTnLst>
                         <p:par>
-                          <p:cTn id="23" fill="hold">
+                          <p:cTn id="30" fill="hold">
                             <p:stCondLst>
                               <p:cond delay="0"/>
                             </p:stCondLst>
                             <p:childTnLst>
                               <p:par>
-                                <p:cTn id="24" presetID="2" presetClass="entr" presetSubtype="4" fill="hold" nodeType="clickEffect">
+                                <p:cTn id="31" presetID="2" presetClass="entr" presetSubtype="4" fill="hold" grpId="0" nodeType="clickEffect">
                                   <p:stCondLst>
                                     <p:cond delay="0"/>
                                   </p:stCondLst>
                                   <p:childTnLst>
                                     <p:set>
                                       <p:cBhvr>
-                                        <p:cTn id="25" dur="1" fill="hold">
+                                        <p:cTn id="32" dur="1" fill="hold">
                                           <p:stCondLst>
                                             <p:cond delay="0"/>
                                           </p:stCondLst>
                                         </p:cTn>
                                         <p:tgtEl>
-                                          <p:spTgt spid="8"/>
+                                          <p:spTgt spid="12"/>
                                         </p:tgtEl>
                                         <p:attrNameLst>
                                           <p:attrName>style.visibility</p:attrName>
@@ -14761,9 +14134,9 @@
                                     </p:set>
                                     <p:anim calcmode="lin" valueType="num">
                                       <p:cBhvr additive="base">
-                                        <p:cTn id="26" dur="500" fill="hold"/>
-                                        <p:tgtEl>
-                                          <p:spTgt spid="8"/>
+                                        <p:cTn id="33" dur="500" fill="hold"/>
+                                        <p:tgtEl>
+                                          <p:spTgt spid="12"/>
                                         </p:tgtEl>
                                         <p:attrNameLst>
                                           <p:attrName>ppt_x</p:attrName>
@@ -14784,9 +14157,9 @@
                                     </p:anim>
                                     <p:anim calcmode="lin" valueType="num">
                                       <p:cBhvr additive="base">
-                                        <p:cTn id="27" dur="500" fill="hold"/>
-                                        <p:tgtEl>
-                                          <p:spTgt spid="8"/>
+                                        <p:cTn id="34" dur="500" fill="hold"/>
+                                        <p:tgtEl>
+                                          <p:spTgt spid="12"/>
                                         </p:tgtEl>
                                         <p:attrNameLst>
                                           <p:attrName>ppt_y</p:attrName>
@@ -14815,32 +14188,32 @@
                     </p:cTn>
                   </p:par>
                   <p:par>
-                    <p:cTn id="28" fill="hold">
+                    <p:cTn id="35" fill="hold">
                       <p:stCondLst>
                         <p:cond delay="indefinite"/>
                       </p:stCondLst>
                       <p:childTnLst>
                         <p:par>
-                          <p:cTn id="29" fill="hold">
+                          <p:cTn id="36" fill="hold">
                             <p:stCondLst>
                               <p:cond delay="0"/>
                             </p:stCondLst>
                             <p:childTnLst>
                               <p:par>
-                                <p:cTn id="30" presetID="2" presetClass="entr" presetSubtype="4" fill="hold" grpId="0" nodeType="clickEffect">
+                                <p:cTn id="37" presetID="2" presetClass="entr" presetSubtype="4" fill="hold" nodeType="clickEffect">
                                   <p:stCondLst>
                                     <p:cond delay="0"/>
                                   </p:stCondLst>
                                   <p:childTnLst>
                                     <p:set>
                                       <p:cBhvr>
-                                        <p:cTn id="31" dur="1" fill="hold">
+                                        <p:cTn id="38" dur="1" fill="hold">
                                           <p:stCondLst>
                                             <p:cond delay="0"/>
                                           </p:stCondLst>
                                         </p:cTn>
                                         <p:tgtEl>
-                                          <p:spTgt spid="12"/>
+                                          <p:spTgt spid="11"/>
                                         </p:tgtEl>
                                         <p:attrNameLst>
                                           <p:attrName>style.visibility</p:attrName>
@@ -14852,9 +14225,9 @@
                                     </p:set>
                                     <p:anim calcmode="lin" valueType="num">
                                       <p:cBhvr additive="base">
-                                        <p:cTn id="32" dur="500" fill="hold"/>
-                                        <p:tgtEl>
-                                          <p:spTgt spid="12"/>
+                                        <p:cTn id="39" dur="500" fill="hold"/>
+                                        <p:tgtEl>
+                                          <p:spTgt spid="11"/>
                                         </p:tgtEl>
                                         <p:attrNameLst>
                                           <p:attrName>ppt_x</p:attrName>
@@ -14875,9 +14248,9 @@
                                     </p:anim>
                                     <p:anim calcmode="lin" valueType="num">
                                       <p:cBhvr additive="base">
-                                        <p:cTn id="33" dur="500" fill="hold"/>
-                                        <p:tgtEl>
-                                          <p:spTgt spid="12"/>
+                                        <p:cTn id="40" dur="500" fill="hold"/>
+                                        <p:tgtEl>
+                                          <p:spTgt spid="11"/>
                                         </p:tgtEl>
                                         <p:attrNameLst>
                                           <p:attrName>ppt_y</p:attrName>
@@ -14906,32 +14279,32 @@
                     </p:cTn>
                   </p:par>
                   <p:par>
-                    <p:cTn id="34" fill="hold">
+                    <p:cTn id="41" fill="hold">
                       <p:stCondLst>
                         <p:cond delay="indefinite"/>
                       </p:stCondLst>
                       <p:childTnLst>
                         <p:par>
-                          <p:cTn id="35" fill="hold">
+                          <p:cTn id="42" fill="hold">
                             <p:stCondLst>
                               <p:cond delay="0"/>
                             </p:stCondLst>
                             <p:childTnLst>
                               <p:par>
-                                <p:cTn id="36" presetID="2" presetClass="entr" presetSubtype="4" fill="hold" nodeType="clickEffect">
+                                <p:cTn id="43" presetID="2" presetClass="entr" presetSubtype="4" fill="hold" nodeType="clickEffect">
                                   <p:stCondLst>
                                     <p:cond delay="0"/>
                                   </p:stCondLst>
                                   <p:childTnLst>
                                     <p:set>
                                       <p:cBhvr>
-                                        <p:cTn id="37" dur="1" fill="hold">
+                                        <p:cTn id="44" dur="1" fill="hold">
                                           <p:stCondLst>
                                             <p:cond delay="0"/>
                                           </p:stCondLst>
                                         </p:cTn>
                                         <p:tgtEl>
-                                          <p:spTgt spid="11"/>
+                                          <p:spTgt spid="13"/>
                                         </p:tgtEl>
                                         <p:attrNameLst>
                                           <p:attrName>style.visibility</p:attrName>
@@ -14943,9 +14316,9 @@
                                     </p:set>
                                     <p:anim calcmode="lin" valueType="num">
                                       <p:cBhvr additive="base">
-                                        <p:cTn id="38" dur="500" fill="hold"/>
-                                        <p:tgtEl>
-                                          <p:spTgt spid="11"/>
+                                        <p:cTn id="45" dur="500" fill="hold"/>
+                                        <p:tgtEl>
+                                          <p:spTgt spid="13"/>
                                         </p:tgtEl>
                                         <p:attrNameLst>
                                           <p:attrName>ppt_x</p:attrName>
@@ -14966,9 +14339,9 @@
                                     </p:anim>
                                     <p:anim calcmode="lin" valueType="num">
                                       <p:cBhvr additive="base">
-                                        <p:cTn id="39" dur="500" fill="hold"/>
-                                        <p:tgtEl>
-                                          <p:spTgt spid="11"/>
+                                        <p:cTn id="46" dur="500" fill="hold"/>
+                                        <p:tgtEl>
+                                          <p:spTgt spid="13"/>
                                         </p:tgtEl>
                                         <p:attrNameLst>
                                           <p:attrName>ppt_y</p:attrName>
@@ -14997,32 +14370,36 @@
                     </p:cTn>
                   </p:par>
                   <p:par>
-                    <p:cTn id="40" fill="hold">
+                    <p:cTn id="47" fill="hold">
                       <p:stCondLst>
                         <p:cond delay="indefinite"/>
                       </p:stCondLst>
                       <p:childTnLst>
                         <p:par>
-                          <p:cTn id="41" fill="hold">
+                          <p:cTn id="48" fill="hold">
                             <p:stCondLst>
                               <p:cond delay="0"/>
                             </p:stCondLst>
                             <p:childTnLst>
                               <p:par>
-                                <p:cTn id="42" presetID="2" presetClass="entr" presetSubtype="4" fill="hold" nodeType="clickEffect">
+                                <p:cTn id="49" presetID="53" presetClass="entr" presetSubtype="16" fill="hold" nodeType="clickEffect">
                                   <p:stCondLst>
                                     <p:cond delay="0"/>
                                   </p:stCondLst>
                                   <p:childTnLst>
                                     <p:set>
                                       <p:cBhvr>
-                                        <p:cTn id="43" dur="1" fill="hold">
+                                        <p:cTn id="50" dur="1" fill="hold">
                                           <p:stCondLst>
                                             <p:cond delay="0"/>
                                           </p:stCondLst>
                                         </p:cTn>
                                         <p:tgtEl>
-                                          <p:spTgt spid="13"/>
+                                          <p:spTgt spid="16">
+                                            <p:txEl>
+                                              <p:pRg st="0" end="0"/>
+                                            </p:txEl>
+                                          </p:spTgt>
                                         </p:tgtEl>
                                         <p:attrNameLst>
                                           <p:attrName>style.visibility</p:attrName>
@@ -15033,130 +14410,35 @@
                                       </p:to>
                                     </p:set>
                                     <p:anim calcmode="lin" valueType="num">
-                                      <p:cBhvr additive="base">
-                                        <p:cTn id="44" dur="500" fill="hold"/>
-                                        <p:tgtEl>
-                                          <p:spTgt spid="13"/>
+                                      <p:cBhvr>
+                                        <p:cTn id="51" dur="500" fill="hold"/>
+                                        <p:tgtEl>
+                                          <p:spTgt spid="16">
+                                            <p:txEl>
+                                              <p:pRg st="0" end="0"/>
+                                            </p:txEl>
+                                          </p:spTgt>
                                         </p:tgtEl>
                                         <p:attrNameLst>
-                                          <p:attrName>ppt_x</p:attrName>
+                                          <p:attrName>ppt_w</p:attrName>
                                         </p:attrNameLst>
                                       </p:cBhvr>
                                       <p:tavLst>
                                         <p:tav tm="0">
                                           <p:val>
-                                            <p:strVal val="#ppt_x"/>
+                                            <p:fltVal val="0"/>
                                           </p:val>
                                         </p:tav>
                                         <p:tav tm="100000">
                                           <p:val>
-                                            <p:strVal val="#ppt_x"/>
+                                            <p:strVal val="#ppt_w"/>
                                           </p:val>
                                         </p:tav>
                                       </p:tavLst>
                                     </p:anim>
                                     <p:anim calcmode="lin" valueType="num">
-                                      <p:cBhvr additive="base">
-                                        <p:cTn id="45" dur="500" fill="hold"/>
-                                        <p:tgtEl>
-                                          <p:spTgt spid="13"/>
-                                        </p:tgtEl>
-                                        <p:attrNameLst>
-                                          <p:attrName>ppt_y</p:attrName>
-                                        </p:attrNameLst>
-                                      </p:cBhvr>
-                                      <p:tavLst>
-                                        <p:tav tm="0">
-                                          <p:val>
-                                            <p:strVal val="1+#ppt_h/2"/>
-                                          </p:val>
-                                        </p:tav>
-                                        <p:tav tm="100000">
-                                          <p:val>
-                                            <p:strVal val="#ppt_y"/>
-                                          </p:val>
-                                        </p:tav>
-                                      </p:tavLst>
-                                    </p:anim>
-                                  </p:childTnLst>
-                                </p:cTn>
-                              </p:par>
-                            </p:childTnLst>
-                          </p:cTn>
-                        </p:par>
-                      </p:childTnLst>
-                    </p:cTn>
-                  </p:par>
-                  <p:par>
-                    <p:cTn id="46" fill="hold">
-                      <p:stCondLst>
-                        <p:cond delay="indefinite"/>
-                      </p:stCondLst>
-                      <p:childTnLst>
-                        <p:par>
-                          <p:cTn id="47" fill="hold">
-                            <p:stCondLst>
-                              <p:cond delay="0"/>
-                            </p:stCondLst>
-                            <p:childTnLst>
-                              <p:par>
-                                <p:cTn id="48" presetID="53" presetClass="entr" presetSubtype="16" fill="hold" nodeType="clickEffect">
-                                  <p:stCondLst>
-                                    <p:cond delay="0"/>
-                                  </p:stCondLst>
-                                  <p:childTnLst>
-                                    <p:set>
-                                      <p:cBhvr>
-                                        <p:cTn id="49" dur="1" fill="hold">
-                                          <p:stCondLst>
-                                            <p:cond delay="0"/>
-                                          </p:stCondLst>
-                                        </p:cTn>
-                                        <p:tgtEl>
-                                          <p:spTgt spid="16">
-                                            <p:txEl>
-                                              <p:pRg st="0" end="0"/>
-                                            </p:txEl>
-                                          </p:spTgt>
-                                        </p:tgtEl>
-                                        <p:attrNameLst>
-                                          <p:attrName>style.visibility</p:attrName>
-                                        </p:attrNameLst>
-                                      </p:cBhvr>
-                                      <p:to>
-                                        <p:strVal val="visible"/>
-                                      </p:to>
-                                    </p:set>
-                                    <p:anim calcmode="lin" valueType="num">
-                                      <p:cBhvr>
-                                        <p:cTn id="50" dur="500" fill="hold"/>
-                                        <p:tgtEl>
-                                          <p:spTgt spid="16">
-                                            <p:txEl>
-                                              <p:pRg st="0" end="0"/>
-                                            </p:txEl>
-                                          </p:spTgt>
-                                        </p:tgtEl>
-                                        <p:attrNameLst>
-                                          <p:attrName>ppt_w</p:attrName>
-                                        </p:attrNameLst>
-                                      </p:cBhvr>
-                                      <p:tavLst>
-                                        <p:tav tm="0">
-                                          <p:val>
-                                            <p:fltVal val="0"/>
-                                          </p:val>
-                                        </p:tav>
-                                        <p:tav tm="100000">
-                                          <p:val>
-                                            <p:strVal val="#ppt_w"/>
-                                          </p:val>
-                                        </p:tav>
-                                      </p:tavLst>
-                                    </p:anim>
-                                    <p:anim calcmode="lin" valueType="num">
-                                      <p:cBhvr>
-                                        <p:cTn id="51" dur="500" fill="hold"/>
+                                      <p:cBhvr>
+                                        <p:cTn id="52" dur="500" fill="hold"/>
                                         <p:tgtEl>
                                           <p:spTgt spid="16">
                                             <p:txEl>
@@ -15183,7 +14465,7 @@
                                     </p:anim>
                                     <p:animEffect transition="in" filter="fade">
                                       <p:cBhvr>
-                                        <p:cTn id="52" dur="500"/>
+                                        <p:cTn id="53" dur="500"/>
                                         <p:tgtEl>
                                           <p:spTgt spid="16">
                                             <p:txEl>
@@ -16029,20 +15311,20 @@
 </file>
 
 <file path=customXml/item2.xml><?xml version="1.0" encoding="utf-8"?>
+<p:properties xmlns:p="http://schemas.microsoft.com/office/2006/metadata/properties" xmlns:xsi="http://www.w3.org/2001/XMLSchema-instance" xmlns:pc="http://schemas.microsoft.com/office/infopath/2007/PartnerControls">
+  <documentManagement>
+    <_activity xmlns="9162bd5b-4ed9-4da3-b376-05204580ba3f" xsi:nil="true"/>
+  </documentManagement>
+</p:properties>
+</file>
+
+<file path=customXml/item3.xml><?xml version="1.0" encoding="utf-8"?>
 <?mso-contentType ?>
 <FormTemplates xmlns="http://schemas.microsoft.com/sharepoint/v3/contenttype/forms">
   <Display>DocumentLibraryForm</Display>
   <Edit>DocumentLibraryForm</Edit>
   <New>DocumentLibraryForm</New>
 </FormTemplates>
-</file>
-
-<file path=customXml/item3.xml><?xml version="1.0" encoding="utf-8"?>
-<p:properties xmlns:p="http://schemas.microsoft.com/office/2006/metadata/properties" xmlns:xsi="http://www.w3.org/2001/XMLSchema-instance" xmlns:pc="http://schemas.microsoft.com/office/infopath/2007/PartnerControls">
-  <documentManagement>
-    <_activity xmlns="9162bd5b-4ed9-4da3-b376-05204580ba3f" xsi:nil="true"/>
-  </documentManagement>
-</p:properties>
 </file>
 
 <file path=customXml/itemProps1.xml><?xml version="1.0" encoding="utf-8"?>
@@ -16065,14 +15347,6 @@
 </file>
 
 <file path=customXml/itemProps2.xml><?xml version="1.0" encoding="utf-8"?>
-<ds:datastoreItem xmlns:ds="http://schemas.openxmlformats.org/officeDocument/2006/customXml" ds:itemID="{3706AB80-2608-47D7-8AC8-FA6BC8A9B27C}">
-  <ds:schemaRefs>
-    <ds:schemaRef ds:uri="http://schemas.microsoft.com/sharepoint/v3/contenttype/forms"/>
-  </ds:schemaRefs>
-</ds:datastoreItem>
-</file>
-
-<file path=customXml/itemProps3.xml><?xml version="1.0" encoding="utf-8"?>
 <ds:datastoreItem xmlns:ds="http://schemas.openxmlformats.org/officeDocument/2006/customXml" ds:itemID="{A6559A34-456E-49A1-8157-9E3D18BFAD36}">
   <ds:schemaRefs>
     <ds:schemaRef ds:uri="9162bd5b-4ed9-4da3-b376-05204580ba3f"/>
@@ -16087,4 +15361,12 @@
     <ds:schemaRef ds:uri="http://www.w3.org/XML/1998/namespace"/>
   </ds:schemaRefs>
 </ds:datastoreItem>
+</file>
+
+<file path=customXml/itemProps3.xml><?xml version="1.0" encoding="utf-8"?>
+<ds:datastoreItem xmlns:ds="http://schemas.openxmlformats.org/officeDocument/2006/customXml" ds:itemID="{3706AB80-2608-47D7-8AC8-FA6BC8A9B27C}">
+  <ds:schemaRefs>
+    <ds:schemaRef ds:uri="http://schemas.microsoft.com/sharepoint/v3/contenttype/forms"/>
+  </ds:schemaRefs>
+</ds:datastoreItem>
 </file>
</xml_diff>